<commit_message>
build: publicar PowerPoint Estilo Profesor entendible
</commit_message>
<xml_diff>
--- a/presentacion/Del_Acero_al_Algoritmo_Estilo_Profesor.pptx
+++ b/presentacion/Del_Acero_al_Algoritmo_Estilo_Profesor.pptx
@@ -4202,7 +4202,7 @@
                 </a:solidFill>
                 <a:latin typeface="Aptos"/>
               </a:rPr>
-              <a:t>Pregunta 3 · ¿Cuándo un arancel es sustantivamente alto?</a:t>
+              <a:t>Pregunta 3 · ¿Qué aranceles están entre los más altos?</a:t>
             </a:r>
           </a:p>
         </p:txBody>
@@ -4237,7 +4237,7 @@
                 </a:solidFill>
                 <a:latin typeface="Aptos"/>
               </a:rPr>
-              <a:t>Criterio definitivo: valores atípicos superiores con Q3 + 1,5 × RIC sobre ofertas únicas.</a:t>
+              <a:t>Usamos el percentil 90 (P90): separa aproximadamente el 10% de ofertas con arancel más alto.</a:t>
             </a:r>
           </a:p>
         </p:txBody>
@@ -4352,7 +4352,7 @@
                 </a:solidFill>
                 <a:latin typeface="Aptos"/>
               </a:rPr>
-              <a:t>Q1</a:t>
+              <a:t>P90</a:t>
             </a:r>
           </a:p>
         </p:txBody>
@@ -4387,7 +4387,7 @@
                 </a:solidFill>
                 <a:latin typeface="Aptos"/>
               </a:rPr>
-              <a:t>$1.616.000</a:t>
+              <a:t>$4.106.400</a:t>
             </a:r>
           </a:p>
         </p:txBody>
@@ -4502,7 +4502,7 @@
                 </a:solidFill>
                 <a:latin typeface="Aptos"/>
               </a:rPr>
-              <a:t>Q3</a:t>
+              <a:t>SIGNIFICADO</a:t>
             </a:r>
           </a:p>
         </p:txBody>
@@ -4537,7 +4537,7 @@
                 </a:solidFill>
                 <a:latin typeface="Aptos"/>
               </a:rPr>
-              <a:t>$2.580.000</a:t>
+              <a:t>90%</a:t>
             </a:r>
           </a:p>
         </p:txBody>
@@ -4652,7 +4652,7 @@
                 </a:solidFill>
                 <a:latin typeface="Aptos"/>
               </a:rPr>
-              <a:t>RIC</a:t>
+              <a:t>GRUPO SUPERIOR</a:t>
             </a:r>
           </a:p>
         </p:txBody>
@@ -4687,7 +4687,7 @@
                 </a:solidFill>
                 <a:latin typeface="Aptos"/>
               </a:rPr>
-              <a:t>$964.000</a:t>
+              <a:t>≈ 10%</a:t>
             </a:r>
           </a:p>
         </p:txBody>
@@ -4802,7 +4802,7 @@
                 </a:solidFill>
                 <a:latin typeface="Aptos"/>
               </a:rPr>
-              <a:t>Límite superior</a:t>
+              <a:t>VALOR MÁXIMO</a:t>
             </a:r>
           </a:p>
         </p:txBody>
@@ -4837,7 +4837,7 @@
                 </a:solidFill>
                 <a:latin typeface="Aptos"/>
               </a:rPr>
-              <a:t>Q3 + 1,5 × RIC = $4.026.000</a:t>
+              <a:t>$8.783.670</a:t>
             </a:r>
           </a:p>
         </p:txBody>
@@ -4997,7 +4997,7 @@
                 </a:solidFill>
                 <a:latin typeface="Aptos"/>
               </a:rPr>
-              <a:t>OFERTAS SOBRE EL LÍMITE</a:t>
+              <a:t>OFERTAS SOBRE P90</a:t>
             </a:r>
           </a:p>
         </p:txBody>
@@ -5032,7 +5032,7 @@
                 </a:solidFill>
                 <a:latin typeface="Aptos"/>
               </a:rPr>
-              <a:t>135</a:t>
+              <a:t>128</a:t>
             </a:r>
           </a:p>
         </p:txBody>
@@ -5262,7 +5262,7 @@
                 </a:solidFill>
                 <a:latin typeface="Aptos"/>
               </a:rPr>
-              <a:t>10,6%</a:t>
+              <a:t>10,1%</a:t>
             </a:r>
           </a:p>
         </p:txBody>
@@ -5492,7 +5492,7 @@
                 </a:solidFill>
                 <a:latin typeface="Aptos"/>
               </a:rPr>
-              <a:t>73 / 62</a:t>
+              <a:t>73 / 55</a:t>
             </a:r>
           </a:p>
         </p:txBody>
@@ -5722,7 +5722,7 @@
                 </a:solidFill>
                 <a:latin typeface="Aptos"/>
               </a:rPr>
-              <a:t>129 / 6</a:t>
+              <a:t>123 / 5</a:t>
             </a:r>
           </a:p>
         </p:txBody>
@@ -5879,7 +5879,7 @@
                 </a:solidFill>
                 <a:latin typeface="Aptos"/>
               </a:rPr>
-              <a:t>Respuesta: </a:t>
+              <a:t>Respuesta: el P90 es $4.106.400. Lo superan 128 ofertas (10,1%). De ellas, 73 son CRUCH y 55 privadas; 123 están en Concepción y 5 en Biobío.</a:t>
             </a:r>
             <a:r>
               <a:rPr sz="960">
@@ -5888,7 +5888,7 @@
                 </a:solidFill>
                 <a:latin typeface="Aptos"/>
               </a:rPr>
-              <a:t>Sí. 135 ofertas superan el límite de $4.026.000. Salud y Tecnología concentran 39 ofertas altas cada una, y la duración mediana de este grupo es 10 semestres frente a 5 en el resto.</a:t>
+              <a:t/>
             </a:r>
           </a:p>
         </p:txBody>
@@ -6105,7 +6105,7 @@
                 </a:solidFill>
                 <a:latin typeface="Aptos"/>
               </a:rPr>
-              <a:t>¿Qué caracteriza a las ofertas de arancel alto?</a:t>
+              <a:t>¿Cómo es el grupo de ofertas sobre P90?</a:t>
             </a:r>
           </a:p>
         </p:txBody>
@@ -6140,7 +6140,7 @@
                 </a:solidFill>
                 <a:latin typeface="Aptos"/>
               </a:rPr>
-              <a:t>Estas variables describen el grupo detectado; no se interpretan como causas del precio.</a:t>
+              <a:t>Describimos el 10% superior de aranceles. Estas variables no explican la causa del precio.</a:t>
             </a:r>
           </a:p>
         </p:txBody>
@@ -6405,7 +6405,7 @@
                 </a:solidFill>
                 <a:latin typeface="Aptos"/>
               </a:rPr>
-              <a:t>62 privadas</a:t>
+              <a:t>55 privadas</a:t>
             </a:r>
           </a:p>
         </p:txBody>
@@ -6600,7 +6600,7 @@
                 </a:solidFill>
                 <a:latin typeface="Aptos"/>
               </a:rPr>
-              <a:t>39 Salud</a:t>
+              <a:t>38 Salud</a:t>
             </a:r>
           </a:p>
         </p:txBody>
@@ -6635,7 +6635,7 @@
                 </a:solidFill>
                 <a:latin typeface="Aptos"/>
               </a:rPr>
-              <a:t>39 Tecnología</a:t>
+              <a:t>38 Tecnología</a:t>
             </a:r>
           </a:p>
         </p:txBody>
@@ -6830,7 +6830,7 @@
                 </a:solidFill>
                 <a:latin typeface="Aptos"/>
               </a:rPr>
-              <a:t>129 Concepción</a:t>
+              <a:t>123 Concepción</a:t>
             </a:r>
           </a:p>
         </p:txBody>
@@ -6865,7 +6865,7 @@
                 </a:solidFill>
                 <a:latin typeface="Aptos"/>
               </a:rPr>
-              <a:t>6 Biobío</a:t>
+              <a:t>5 Biobío</a:t>
             </a:r>
           </a:p>
         </p:txBody>
@@ -7217,7 +7217,7 @@
                 </a:solidFill>
                 <a:latin typeface="Aptos"/>
               </a:rPr>
-              <a:t>Lectura: </a:t>
+              <a:t>Lectura: vemos diferencias por institución, área, provincia y duración, pero ninguna de ellas puede presentarse como causa del arancel.</a:t>
             </a:r>
             <a:r>
               <a:rPr sz="960">
@@ -7226,7 +7226,7 @@
                 </a:solidFill>
                 <a:latin typeface="Aptos"/>
               </a:rPr>
-              <a:t>Las ofertas altas aparecen asociadas con determinadas instituciones, áreas, territorio y duración. La base no permite afirmar que alguna de estas variables sea la causa del precio.</a:t>
+              <a:t/>
             </a:r>
           </a:p>
         </p:txBody>
@@ -7478,7 +7478,7 @@
                 </a:solidFill>
                 <a:latin typeface="Aptos"/>
               </a:rPr>
-              <a:t>La proporción y el volumen absoluto cuentan historias distintas.</a:t>
+              <a:t>Porcentaje y cantidad no significan lo mismo: debemos mirar ambos.</a:t>
             </a:r>
           </a:p>
         </p:txBody>
@@ -8355,7 +8355,7 @@
                 </a:solidFill>
                 <a:latin typeface="Aptos"/>
               </a:rPr>
-              <a:t>Hallazgo territorial: </a:t>
+              <a:t>En simple: Arauco tiene el mayor porcentaje dentro de su provincia, pero Concepción tiene muchas más matrículas transformadoras en cantidad total.</a:t>
             </a:r>
             <a:r>
               <a:rPr sz="960">
@@ -8364,7 +8364,7 @@
                 </a:solidFill>
                 <a:latin typeface="Aptos"/>
               </a:rPr>
-              <a:t>Arauco tiene la mayor proporción relativa de matrícula transformadora, pero Concepción concentra por lejos el mayor volumen absoluto. No confundimos porcentaje con cantidad.</a:t>
+              <a:t/>
             </a:r>
           </a:p>
         </p:txBody>
@@ -8581,7 +8581,7 @@
                 </a:solidFill>
                 <a:latin typeface="Aptos"/>
               </a:rPr>
-              <a:t>Interpretar bien también es parte de la nota</a:t>
+              <a:t>Qué podemos concluir y qué no</a:t>
             </a:r>
           </a:p>
         </p:txBody>
@@ -8616,7 +8616,7 @@
                 </a:solidFill>
                 <a:latin typeface="Aptos"/>
               </a:rPr>
-              <a:t>La rúbrica exige resultados correctos y una interpretación coherente con el análisis.</a:t>
+              <a:t>Los datos permiten describir diferencias y asociaciones, pero no demostrar causas.</a:t>
             </a:r>
           </a:p>
         </p:txBody>
@@ -9306,7 +9306,7 @@
                 </a:solidFill>
                 <a:latin typeface="Aptos"/>
               </a:rPr>
-              <a:t>Qué ofertas superan el criterio Q3 + 1,5 × RIC.</a:t>
+              <a:t>Qué ofertas quedan por sobre el percentil 90.</a:t>
             </a:r>
           </a:p>
         </p:txBody>
@@ -10833,7 +10833,7 @@
                 </a:solidFill>
                 <a:latin typeface="Aptos"/>
               </a:rPr>
-              <a:t>135 de 1.273 ofertas superan el límite de $4.026.000 definido con Q3 + 1,5 × RIC.</a:t>
+              <a:t>128 de 1.273 ofertas superan el P90 de $4.106.400, equivalente a 10,1% del total.</a:t>
             </a:r>
           </a:p>
         </p:txBody>
@@ -10955,7 +10955,7 @@
                 </a:solidFill>
                 <a:latin typeface="Aptos"/>
               </a:rPr>
-              <a:t>Respuesta a la pregunta central: </a:t>
+              <a:t>Respuesta central: en 2021 el bloque productivo tiene mayor peso que el transformador. Es una fotografía descriptiva de la matrícula, no una prueba de déficit ni de causalidad.</a:t>
             </a:r>
             <a:r>
               <a:rPr sz="960">
@@ -10964,7 +10964,7 @@
                 </a:solidFill>
                 <a:latin typeface="Aptos"/>
               </a:rPr>
-              <a:t>La línea base 2021 muestra un capital humano con mayor peso relativo en actividades productivas tradicionales que en capacidades transformadoras. La brecha observada es descriptiva y abre una pregunta futura, no una conclusión causal.</a:t>
+              <a:t/>
             </a:r>
           </a:p>
         </p:txBody>
@@ -11606,7 +11606,7 @@
                 </a:solidFill>
                 <a:latin typeface="Aptos"/>
               </a:rPr>
-              <a:t>Notebook final: 71/71 celdas ejecutadas · 0 errores</a:t>
+              <a:t>Notebook final ejecutado · 0 errores</a:t>
             </a:r>
           </a:p>
         </p:txBody>
@@ -12336,7 +12336,7 @@
                           </a:solidFill>
                           <a:latin typeface="Aptos"/>
                         </a:rPr>
-                        <a:t>Preguntas 1 y 2</a:t>
+                        <a:t>Preguntas 1, 2 y 3</a:t>
                       </a:r>
                     </a:p>
                   </a:txBody>
@@ -12384,7 +12384,7 @@
                           </a:solidFill>
                           <a:latin typeface="Aptos"/>
                         </a:rPr>
-                        <a:t>rango, varianza, std, CV, RIC, agg, isin</a:t>
+                        <a:t>rango, std, CV, agg, isin</a:t>
                       </a:r>
                     </a:p>
                   </a:txBody>
@@ -12407,7 +12407,7 @@
                           </a:solidFill>
                           <a:latin typeface="Aptos"/>
                         </a:rPr>
-                        <a:t>Pregunta 3 y comparación entre grupos</a:t>
+                        <a:t>Dispersión general y comparación entre grupos</a:t>
                       </a:r>
                     </a:p>
                   </a:txBody>
@@ -12634,7 +12634,7 @@
                 </a:solidFill>
                 <a:latin typeface="Aptos"/>
               </a:rPr>
-              <a:t>ANEXO · Fórmulas que debes saber explicar</a:t>
+              <a:t>ANEXO · Conceptos que debes saber explicar</a:t>
             </a:r>
           </a:p>
         </p:txBody>
@@ -12669,7 +12669,7 @@
                 </a:solidFill>
                 <a:latin typeface="Aptos"/>
               </a:rPr>
-              <a:t>No basta con leerlas: debes decir qué mide cada una y por qué se usa.</a:t>
+              <a:t>La clave es poder explicar qué mide cada concepto y cuándo lo usamos en el trabajo.</a:t>
             </a:r>
           </a:p>
         </p:txBody>
@@ -13234,7 +13234,7 @@
                 </a:solidFill>
                 <a:latin typeface="Aptos"/>
               </a:rPr>
-              <a:t>Rango intercuartílico</a:t>
+              <a:t>Percentil 90</a:t>
             </a:r>
           </a:p>
         </p:txBody>
@@ -13269,7 +13269,7 @@
                 </a:solidFill>
                 <a:latin typeface="Aptos"/>
               </a:rPr>
-              <a:t>RIC = Q3 − Q1</a:t>
+              <a:t>quantile(0.90)</a:t>
             </a:r>
           </a:p>
         </p:txBody>
@@ -13304,7 +13304,7 @@
                 </a:solidFill>
                 <a:latin typeface="Aptos"/>
               </a:rPr>
-              <a:t>Amplitud del 50% central de los datos.</a:t>
+              <a:t>Valor que deja aproximadamente 90% de los datos en o bajo ese punto.</a:t>
             </a:r>
           </a:p>
         </p:txBody>
@@ -13384,7 +13384,7 @@
                 </a:solidFill>
                 <a:latin typeface="Aptos"/>
               </a:rPr>
-              <a:t>Límite superior</a:t>
+              <a:t>Desviación estándar</a:t>
             </a:r>
           </a:p>
         </p:txBody>
@@ -13419,7 +13419,7 @@
                 </a:solidFill>
                 <a:latin typeface="Aptos"/>
               </a:rPr>
-              <a:t>Q3 + 1,5 × RIC</a:t>
+              <a:t>std()</a:t>
             </a:r>
           </a:p>
         </p:txBody>
@@ -13454,7 +13454,7 @@
                 </a:solidFill>
                 <a:latin typeface="Aptos"/>
               </a:rPr>
-              <a:t>Criterio para identificar valores atípicamente altos.</a:t>
+              <a:t>Mide cuánto se alejan los valores respecto de su media, en la escala original.</a:t>
             </a:r>
           </a:p>
         </p:txBody>
@@ -14431,7 +14431,7 @@
                 </a:solidFill>
                 <a:latin typeface="Aptos"/>
               </a:rPr>
-              <a:t>¿Qué es RIC?</a:t>
+              <a:t>¿Por qué usamos P90?</a:t>
             </a:r>
           </a:p>
         </p:txBody>
@@ -14466,7 +14466,7 @@
                 </a:solidFill>
                 <a:latin typeface="Aptos"/>
               </a:rPr>
-              <a:t>Es Q3 menos Q1: la amplitud que contiene el 50% central de los datos.</a:t>
+              <a:t>Porque permite separar de forma objetiva aproximadamente el 10% de ofertas con arancel más alto usando percentiles vistos en clase.</a:t>
             </a:r>
           </a:p>
         </p:txBody>
@@ -14833,7 +14833,7 @@
                 </a:solidFill>
                 <a:latin typeface="Aptos"/>
               </a:rPr>
-              <a:t>Una misma base exige distintas unidades de análisis según la pregunta.</a:t>
+              <a:t>Usamos la misma base, pero cada pregunta necesita una unidad de análisis distinta.</a:t>
             </a:r>
           </a:p>
         </p:txBody>
@@ -15328,7 +15328,7 @@
                 </a:solidFill>
                 <a:latin typeface="Aptos"/>
               </a:rPr>
-              <a:t>personas y estructura formativa</a:t>
+              <a:t>matrículas y estructura formativa</a:t>
             </a:r>
           </a:p>
         </p:txBody>
@@ -15558,7 +15558,7 @@
                 </a:solidFill>
                 <a:latin typeface="Aptos"/>
               </a:rPr>
-              <a:t>análisis de arancel asociado a matrículas</a:t>
+              <a:t>matrículas con arancel mayor que $0</a:t>
             </a:r>
           </a:p>
         </p:txBody>
@@ -15788,7 +15788,7 @@
                 </a:solidFill>
                 <a:latin typeface="Aptos"/>
               </a:rPr>
-              <a:t>comparación real de precios</a:t>
+              <a:t>precios sin repetir la misma oferta</a:t>
             </a:r>
           </a:p>
         </p:txBody>
@@ -15910,7 +15910,7 @@
                 </a:solidFill>
                 <a:latin typeface="Aptos"/>
               </a:rPr>
-              <a:t>Decisión metodológica: </a:t>
+              <a:t>En simple: para comparar precios, una misma carrera no puede repetir su arancel por cada estudiante. Por eso trabajamos con 1.273 ofertas únicas.</a:t>
             </a:r>
             <a:r>
               <a:rPr sz="960">
@@ -15919,7 +15919,7 @@
                 </a:solidFill>
                 <a:latin typeface="Aptos"/>
               </a:rPr>
-              <a:t>Para estudiar cuánto cuesta una carrera no contamos el mismo arancel una vez por cada estudiante. Por eso eliminamos ofertas repetidas y trabajamos con 1.273 ofertas únicas.</a:t>
+              <a:t/>
             </a:r>
           </a:p>
         </p:txBody>
@@ -16596,7 +16596,7 @@
                 </a:solidFill>
                 <a:latin typeface="Aptos"/>
               </a:rPr>
-              <a:t>Herramientas estadísticas utilizadas</a:t>
+              <a:t>Qué herramientas usamos y para qué</a:t>
             </a:r>
           </a:p>
         </p:txBody>
@@ -16631,7 +16631,7 @@
                 </a:solidFill>
                 <a:latin typeface="Aptos"/>
               </a:rPr>
-              <a:t>El notebook aplica los contenidos de los laboratorios del profesor, no técnicas externas al curso.</a:t>
+              <a:t>Cada herramienta del notebook corresponde a contenidos trabajados en los laboratorios del profesor.</a:t>
             </a:r>
           </a:p>
         </p:txBody>
@@ -16861,7 +16861,7 @@
                 </a:solidFill>
                 <a:latin typeface="Aptos"/>
               </a:rPr>
-              <a:t>fi · hi · acumuladas</a:t>
+              <a:t>cuántos · porcentajes · acumulados</a:t>
             </a:r>
           </a:p>
         </p:txBody>
@@ -17091,7 +17091,7 @@
                 </a:solidFill>
                 <a:latin typeface="Aptos"/>
               </a:rPr>
-              <a:t>media · mediana · moda</a:t>
+              <a:t>valor típico o central</a:t>
             </a:r>
           </a:p>
         </p:txBody>
@@ -17321,7 +17321,7 @@
                 </a:solidFill>
                 <a:latin typeface="Aptos"/>
               </a:rPr>
-              <a:t>P25 · P50 · P75 · P90</a:t>
+              <a:t>posición dentro de la distribución</a:t>
             </a:r>
           </a:p>
         </p:txBody>
@@ -17551,7 +17551,7 @@
                 </a:solidFill>
                 <a:latin typeface="Aptos"/>
               </a:rPr>
-              <a:t>rango · varianza · DE · CV · RIC</a:t>
+              <a:t>rango · desviación estándar · CV</a:t>
             </a:r>
           </a:p>
         </p:txBody>
@@ -17586,7 +17586,7 @@
                 </a:solidFill>
                 <a:latin typeface="Aptos"/>
               </a:rPr>
-              <a:t>var() · std()</a:t>
+              <a:t>std()</a:t>
             </a:r>
           </a:p>
         </p:txBody>
@@ -17781,7 +17781,7 @@
                 </a:solidFill>
                 <a:latin typeface="Aptos"/>
               </a:rPr>
-              <a:t>cruces y comparación entre grupos</a:t>
+              <a:t>comparar dos variables o grupos</a:t>
             </a:r>
           </a:p>
         </p:txBody>
@@ -17938,7 +17938,7 @@
                 </a:solidFill>
                 <a:latin typeface="Aptos"/>
               </a:rPr>
-              <a:t>Criterio de evaluación: </a:t>
+              <a:t>Idea clave: primero elegimos la herramienta, después calculamos, mostramos el resultado y finalmente lo interpretamos.</a:t>
             </a:r>
             <a:r>
               <a:rPr sz="960">
@@ -17947,7 +17947,7 @@
                 </a:solidFill>
                 <a:latin typeface="Aptos"/>
               </a:rPr>
-              <a:t>Cada resultado de la presentación sigue la secuencia que exige la rúbrica: herramienta seleccionada → cálculo → resultado → interpretación.</a:t>
+              <a:t/>
             </a:r>
           </a:p>
         </p:txBody>
@@ -18575,7 +18575,7 @@
                 </a:solidFill>
                 <a:latin typeface="Aptos"/>
               </a:rPr>
-              <a:t>La distribución global es relativamente equilibrada, aunque cambia según el área de estudio.</a:t>
+              <a:t>En total hay más mujeres (54,3%) que hombres (45,7%); la distribución cambia según el área.</a:t>
             </a:r>
           </a:p>
         </p:txBody>
@@ -19737,7 +19737,7 @@
                 </a:solidFill>
                 <a:latin typeface="Aptos"/>
               </a:rPr>
-              <a:t>Lectura descriptiva: </a:t>
+              <a:t>Lectura: Tecnología (27,6%) y Salud (24,3%) concentran 51,9% de la matrícula. La base muestra el patrón, no su causa.</a:t>
             </a:r>
             <a:r>
               <a:rPr sz="960">
@@ -19746,7 +19746,7 @@
                 </a:solidFill>
                 <a:latin typeface="Aptos"/>
               </a:rPr>
-              <a:t>Tecnología y Salud concentran más de la mitad de la matrícula observada. Esta es una descripción de la base, no una explicación causal de por qué ocurre.</a:t>
+              <a:t/>
             </a:r>
           </a:p>
         </p:txBody>
@@ -20869,7 +20869,7 @@
                 </a:solidFill>
                 <a:latin typeface="Aptos"/>
               </a:rPr>
-              <a:t>Agrupamos carreras en familias estratégicas para construir una lectura regional del capital humano.</a:t>
+              <a:t>Agrupamos carreras en 9 familias para comparar formación productiva y formación transformadora.</a:t>
             </a:r>
           </a:p>
         </p:txBody>
@@ -22466,7 +22466,7 @@
                 </a:solidFill>
                 <a:latin typeface="Aptos"/>
               </a:rPr>
-              <a:t>Regla de clasificación: </a:t>
+              <a:t>Importante: esta clasificación fue creada para el trabajo. No es oficial y cada carrera aparece en una sola familia para no contarla dos veces.</a:t>
             </a:r>
             <a:r>
               <a:rPr sz="960">
@@ -22475,7 +22475,7 @@
                 </a:solidFill>
                 <a:latin typeface="Aptos"/>
               </a:rPr>
-              <a:t>Es una taxonomía creada para este trabajo, no una clasificación oficial. Cada carrera se asigna a una sola familia para evitar doble conteo.</a:t>
+              <a:t/>
             </a:r>
           </a:p>
         </p:txBody>
@@ -22727,7 +22727,7 @@
                 </a:solidFill>
                 <a:latin typeface="Aptos"/>
               </a:rPr>
-              <a:t>La comparación describe la composición de la matrícula de pregrado en 2021.</a:t>
+              <a:t>Comparamos cuánto pesa cada bloque dentro de la matrícula de pregrado de 2021.</a:t>
             </a:r>
           </a:p>
         </p:txBody>
@@ -23434,7 +23434,7 @@
                 </a:solidFill>
                 <a:latin typeface="Aptos"/>
               </a:rPr>
-              <a:t>Interpretación correcta: </a:t>
+              <a:t>En simple: hay cerca de 2,9 matrículas productivas por cada transformadora. Es una diferencia descriptiva, no prueba un déficit profesional.</a:t>
             </a:r>
             <a:r>
               <a:rPr sz="960">
@@ -23443,7 +23443,7 @@
                 </a:solidFill>
                 <a:latin typeface="Aptos"/>
               </a:rPr>
-              <a:t>En la fotografía educativa de 2021, el bloque productivo tiene un peso cercano a tres veces el transformador. Esto no demuestra déficit de profesionales ni atraso de la educación.</a:t>
+              <a:t/>
             </a:r>
           </a:p>
         </p:txBody>
@@ -23695,7 +23695,7 @@
                 </a:solidFill>
                 <a:latin typeface="Aptos"/>
               </a:rPr>
-              <a:t>Criterio: comparar la mediana del arancel usando 1.273 ofertas académicas únicas.</a:t>
+              <a:t>Usamos 1.273 ofertas únicas y comparamos su arancel mediano por área.</a:t>
             </a:r>
           </a:p>
         </p:txBody>
@@ -25337,7 +25337,7 @@
                 </a:solidFill>
                 <a:latin typeface="Aptos"/>
               </a:rPr>
-              <a:t>Respuesta: </a:t>
+              <a:t>Respuesta: Sí. La mediana global es $2.030.000. Derecho, Ciencias Básicas y Agropecuaria están por encima. Usamos mediana porque los valores extremos la afectan menos.</a:t>
             </a:r>
             <a:r>
               <a:rPr sz="960">
@@ -25346,7 +25346,7 @@
                 </a:solidFill>
                 <a:latin typeface="Aptos"/>
               </a:rPr>
-              <a:t>Sí. Derecho, Ciencias Básicas y Agropecuaria presentan medianas superiores a la mediana global de $2.030.000. Usamos mediana porque es menos sensible a valores extremos.</a:t>
+              <a:t/>
             </a:r>
           </a:p>
         </p:txBody>
@@ -25598,7 +25598,7 @@
                 </a:solidFill>
                 <a:latin typeface="Aptos"/>
               </a:rPr>
-              <a:t>Comparamos grupos de edad con tablas de contingencia y frecuencias relativas.</a:t>
+              <a:t>Comparamos qué tipo de institución aparece con mayor frecuencia en dos grupos de edad.</a:t>
             </a:r>
           </a:p>
         </p:txBody>
@@ -26625,7 +26625,7 @@
                 </a:solidFill>
                 <a:latin typeface="Aptos"/>
               </a:rPr>
-              <a:t>Interpretación: </a:t>
+              <a:t>Respuesta: la composición institucional cambia según el grupo de edad. Observamos una asociación, pero no podemos decir que la edad cause la elección.</a:t>
             </a:r>
             <a:r>
               <a:rPr sz="960">
@@ -26634,7 +26634,7 @@
                 </a:solidFill>
                 <a:latin typeface="Aptos"/>
               </a:rPr>
-              <a:t>La distribución institucional cambia entre grupos de edad. La base permite describir asociación, pero no afirmar que la edad cause la elección de institución.</a:t>
+              <a:t/>
             </a:r>
           </a:p>
         </p:txBody>

</xml_diff>

<commit_message>
build: alinear PowerPoint con rúbrica y notebook
</commit_message>
<xml_diff>
--- a/presentacion/Del_Acero_al_Algoritmo_Estilo_Profesor.pptx
+++ b/presentacion/Del_Acero_al_Algoritmo_Estilo_Profesor.pptx
@@ -3737,7 +3737,7 @@
                 </a:solidFill>
                 <a:latin typeface="Noto Sans"/>
               </a:rPr>
-              <a:t>Usamos el percentil 90 (P90) para estudiar aproximadamente el 10% superior de las ofertas.</a:t>
+              <a:t>La pauta pide diseñar un criterio reproducible; usamos el percentil 90 (P90), trabajado en el Laboratorio 4.</a:t>
             </a:r>
           </a:p>
         </p:txBody>
@@ -9483,7 +9483,7 @@
                 </a:solidFill>
                 <a:latin typeface="Noto Sans"/>
               </a:rPr>
-              <a:t>read_excel, head, tail, info, filtros</a:t>
+              <a:t>read_excel, head, info, filtros</a:t>
             </a:r>
           </a:p>
         </p:txBody>
@@ -9563,7 +9563,7 @@
                 </a:solidFill>
                 <a:latin typeface="Noto Sans"/>
               </a:rPr>
-              <a:t>Carga y preparación de la base</a:t>
+              <a:t>Carga, revisión y preparación</a:t>
             </a:r>
           </a:p>
         </p:txBody>
@@ -9963,7 +9963,7 @@
                 </a:solidFill>
                 <a:latin typeface="Noto Sans"/>
               </a:rPr>
-              <a:t>groupby().size(), relativas, acumuladas</a:t>
+              <a:t>groupby().size(), relativas, cumsum()</a:t>
             </a:r>
           </a:p>
         </p:txBody>
@@ -10203,7 +10203,7 @@
                 </a:solidFill>
                 <a:latin typeface="Noto Sans"/>
               </a:rPr>
-              <a:t>barras, circular, histogramas, scatter</a:t>
+              <a:t>barras y subplots</a:t>
             </a:r>
           </a:p>
         </p:txBody>
@@ -10283,7 +10283,7 @@
                 </a:solidFill>
                 <a:latin typeface="Noto Sans"/>
               </a:rPr>
-              <a:t>Visualización de distribuciones</a:t>
+              <a:t>Distribuciones y comparación</a:t>
             </a:r>
           </a:p>
         </p:txBody>
@@ -11590,7 +11590,7 @@
                 </a:solidFill>
                 <a:latin typeface="Noto Sans"/>
               </a:rPr>
-              <a:t>Porque permite separar aproximadamente el 10% superior usando percentiles trabajados en clase.</a:t>
+              <a:t>Porque la pauta pide diseñar un criterio reproducible y el P90 usa percentiles trabajados en el Laboratorio 4.</a:t>
             </a:r>
           </a:p>
         </p:txBody>
@@ -14309,6 +14309,41 @@
                 <a:latin typeface="Noto Sans"/>
               </a:rPr>
               <a:t>No repetimos el mismo arancel una vez por cada estudiante. Las 1.273 ofertas únicas permiten comparar precios sin que una carrera con más matrícula pese artificialmente más.</a:t>
+            </a:r>
+          </a:p>
+        </p:txBody>
+      </p:sp>
+      <p:sp>
+        <p:nvSpPr>
+          <p:cNvPr id="39" name="TextBox 38"/>
+          <p:cNvSpPr txBox="1"/>
+          <p:nvPr/>
+        </p:nvSpPr>
+        <p:spPr>
+          <a:xfrm>
+            <a:off x="713232" y="5742432"/>
+            <a:ext cx="10899648" cy="310896"/>
+          </a:xfrm>
+          <a:prstGeom prst="rect">
+            <a:avLst/>
+          </a:prstGeom>
+          <a:noFill/>
+        </p:spPr>
+        <p:txBody>
+          <a:bodyPr wrap="square" anchor="ctr" lIns="18288" rIns="18288" tIns="18288" bIns="18288">
+            <a:spAutoFit/>
+          </a:bodyPr>
+          <a:lstStyle/>
+          <a:p>
+            <a:pPr algn="ctr"/>
+            <a:r>
+              <a:rPr sz="850" b="1">
+                <a:solidFill>
+                  <a:srgbClr val="596C82"/>
+                </a:solidFill>
+                <a:latin typeface="Noto Sans"/>
+              </a:rPr>
+              <a:t>Control de calidad: 0 duplicados completos · nulos solo en acreditación · 26 registros con arancel $0 excluidos del análisis de precios.</a:t>
             </a:r>
           </a:p>
         </p:txBody>

</xml_diff>

<commit_message>
build: reforzar respuestas según pauta oficial
</commit_message>
<xml_diff>
--- a/presentacion/Del_Acero_al_Algoritmo_Estilo_Profesor.pptx
+++ b/presentacion/Del_Acero_al_Algoritmo_Estilo_Profesor.pptx
@@ -5723,8 +5723,8 @@
         </p:nvSpPr>
         <p:spPr>
           <a:xfrm>
-            <a:off x="713232" y="4956048"/>
-            <a:ext cx="10625328" cy="804672"/>
+            <a:off x="713232" y="4828032"/>
+            <a:ext cx="10625328" cy="1051560"/>
           </a:xfrm>
           <a:prstGeom prst="roundRect">
             <a:avLst/>
@@ -5768,14 +5768,14 @@
         </p:nvSpPr>
         <p:spPr>
           <a:xfrm>
-            <a:off x="713232" y="4956048"/>
-            <a:ext cx="32004" cy="804672"/>
+            <a:off x="713232" y="4828032"/>
+            <a:ext cx="32004" cy="1051560"/>
           </a:xfrm>
           <a:prstGeom prst="rect">
             <a:avLst/>
           </a:prstGeom>
           <a:solidFill>
-            <a:srgbClr val="00AD9F"/>
+            <a:srgbClr val="F59753"/>
           </a:solidFill>
           <a:ln>
             <a:noFill/>
@@ -5811,7 +5811,7 @@
         </p:nvSpPr>
         <p:spPr>
           <a:xfrm>
-            <a:off x="941832" y="5065776"/>
+            <a:off x="941832" y="4937760"/>
             <a:ext cx="10213848" cy="219456"/>
           </a:xfrm>
           <a:prstGeom prst="rect">
@@ -5833,7 +5833,7 @@
                 </a:solidFill>
                 <a:latin typeface="Noto Sans"/>
               </a:rPr>
-              <a:t>LECTURA</a:t>
+              <a:t>EXPLICACIÓN ENCONTRADA</a:t>
             </a:r>
           </a:p>
         </p:txBody>
@@ -5846,8 +5846,8 @@
         </p:nvSpPr>
         <p:spPr>
           <a:xfrm>
-            <a:off x="941832" y="5303520"/>
-            <a:ext cx="10213848" cy="384048"/>
+            <a:off x="941832" y="5175504"/>
+            <a:ext cx="10213848" cy="630936"/>
           </a:xfrm>
           <a:prstGeom prst="rect">
             <a:avLst/>
@@ -5868,7 +5868,7 @@
                 </a:solidFill>
                 <a:latin typeface="Noto Sans"/>
               </a:rPr>
-              <a:t>Las ofertas altas se concentran en determinados tipos de institución, áreas y territorio, y tienen mayor duración mediana. La base no demuestra que estas variables causen el precio.</a:t>
+              <a:t>Las ofertas sobre P90 se concentran en universidades, Salud y Tecnología, carreras de mayor duración y especialmente en Concepción. La concentración territorial aporta contexto regional; estas asociaciones no demuestran causalidad.</a:t>
             </a:r>
           </a:p>
         </p:txBody>
@@ -23822,7 +23822,7 @@
                 </a:solidFill>
                 <a:latin typeface="Noto Sans"/>
               </a:rPr>
-              <a:t>RESPUESTA</a:t>
+              <a:t>CRITERIO Y RESPUESTA</a:t>
             </a:r>
           </a:p>
         </p:txBody>
@@ -23857,7 +23857,7 @@
                 </a:solidFill>
                 <a:latin typeface="Noto Sans"/>
               </a:rPr>
-              <a:t>Sí. Derecho, Ciencias Básicas y Agropecuaria presentan medianas por encima de la mediana global. Usamos mediana porque los valores extremos la afectan menos.</a:t>
+              <a:t>Criterio: comparar la mediana por área con la mediana global, porque la mediana es menos sensible a valores extremos. Resultado: Derecho, Ciencias Básicas y Agropecuaria quedan por encima de $2.030.000.</a:t>
             </a:r>
           </a:p>
         </p:txBody>

</xml_diff>

<commit_message>
build: agregar clasificación de variables
</commit_message>
<xml_diff>
--- a/presentacion/Del_Acero_al_Algoritmo_Estilo_Profesor.pptx
+++ b/presentacion/Del_Acero_al_Algoritmo_Estilo_Profesor.pptx
@@ -22,6 +22,7 @@
     <p:sldId id="270" r:id="rId21"/>
     <p:sldId id="271" r:id="rId22"/>
     <p:sldId id="272" r:id="rId23"/>
+    <p:sldId id="273" r:id="rId24"/>
   </p:sldIdLst>
   <p:sldSz cx="12191695" cy="6858000" type="screen4x3"/>
   <p:notesSz cx="6858000" cy="9144000"/>
@@ -12888,6 +12889,1864 @@
                 <a:latin typeface="Noto Sans"/>
               </a:rPr>
               <a:t>Resultado observado ≠ causa demostrada. En la defensa, usa “se observa”, “se asocia” o “la base muestra”.</a:t>
+            </a:r>
+          </a:p>
+        </p:txBody>
+      </p:sp>
+    </p:spTree>
+  </p:cSld>
+  <p:clrMapOvr>
+    <a:masterClrMapping/>
+  </p:clrMapOvr>
+</p:sld>
+</file>
+
+<file path=ppt/slides/slide18.xml><?xml version="1.0" encoding="utf-8"?>
+<p:sld xmlns:a="http://schemas.openxmlformats.org/drawingml/2006/main" xmlns:p="http://schemas.openxmlformats.org/presentationml/2006/main" xmlns:r="http://schemas.openxmlformats.org/officeDocument/2006/relationships">
+  <p:cSld>
+    <p:bg>
+      <p:bgPr>
+        <a:solidFill>
+          <a:srgbClr val="FFFFFF"/>
+        </a:solidFill>
+        <a:effectLst/>
+      </p:bgPr>
+    </p:bg>
+    <p:spTree>
+      <p:nvGrpSpPr>
+        <p:cNvPr id="1" name=""/>
+        <p:cNvGrpSpPr/>
+        <p:nvPr/>
+      </p:nvGrpSpPr>
+      <p:grpSpPr/>
+      <p:sp>
+        <p:nvSpPr>
+          <p:cNvPr id="2" name="Rectangle 1"/>
+          <p:cNvSpPr/>
+          <p:nvPr/>
+        </p:nvSpPr>
+        <p:spPr>
+          <a:xfrm>
+            <a:off x="0" y="0"/>
+            <a:ext cx="12191695" cy="50292"/>
+          </a:xfrm>
+          <a:prstGeom prst="rect">
+            <a:avLst/>
+          </a:prstGeom>
+          <a:solidFill>
+            <a:srgbClr val="00899A"/>
+          </a:solidFill>
+          <a:ln>
+            <a:noFill/>
+          </a:ln>
+        </p:spPr>
+        <p:style>
+          <a:lnRef idx="1">
+            <a:schemeClr val="accent1"/>
+          </a:lnRef>
+          <a:fillRef idx="3">
+            <a:schemeClr val="accent1"/>
+          </a:fillRef>
+          <a:effectRef idx="2">
+            <a:schemeClr val="accent1"/>
+          </a:effectRef>
+          <a:fontRef idx="minor">
+            <a:schemeClr val="lt1"/>
+          </a:fontRef>
+        </p:style>
+        <p:txBody>
+          <a:bodyPr rtlCol="0" anchor="ctr"/>
+          <a:lstStyle/>
+          <a:p>
+            <a:pPr algn="ctr"/>
+          </a:p>
+        </p:txBody>
+      </p:sp>
+      <p:sp>
+        <p:nvSpPr>
+          <p:cNvPr id="3" name="Rectangle 2"/>
+          <p:cNvSpPr/>
+          <p:nvPr/>
+        </p:nvSpPr>
+        <p:spPr>
+          <a:xfrm>
+            <a:off x="530352" y="438912"/>
+            <a:ext cx="41148" cy="384048"/>
+          </a:xfrm>
+          <a:prstGeom prst="rect">
+            <a:avLst/>
+          </a:prstGeom>
+          <a:solidFill>
+            <a:srgbClr val="00AD9F"/>
+          </a:solidFill>
+          <a:ln>
+            <a:noFill/>
+          </a:ln>
+        </p:spPr>
+        <p:style>
+          <a:lnRef idx="1">
+            <a:schemeClr val="accent1"/>
+          </a:lnRef>
+          <a:fillRef idx="3">
+            <a:schemeClr val="accent1"/>
+          </a:fillRef>
+          <a:effectRef idx="2">
+            <a:schemeClr val="accent1"/>
+          </a:effectRef>
+          <a:fontRef idx="minor">
+            <a:schemeClr val="lt1"/>
+          </a:fontRef>
+        </p:style>
+        <p:txBody>
+          <a:bodyPr rtlCol="0" anchor="ctr"/>
+          <a:lstStyle/>
+          <a:p>
+            <a:pPr algn="ctr"/>
+          </a:p>
+        </p:txBody>
+      </p:sp>
+      <p:sp>
+        <p:nvSpPr>
+          <p:cNvPr id="4" name="TextBox 3"/>
+          <p:cNvSpPr txBox="1"/>
+          <p:nvPr/>
+        </p:nvSpPr>
+        <p:spPr>
+          <a:xfrm>
+            <a:off x="713232" y="384048"/>
+            <a:ext cx="10378440" cy="566928"/>
+          </a:xfrm>
+          <a:prstGeom prst="rect">
+            <a:avLst/>
+          </a:prstGeom>
+          <a:noFill/>
+        </p:spPr>
+        <p:txBody>
+          <a:bodyPr wrap="square" anchor="ctr" lIns="18288" rIns="18288" tIns="18288" bIns="18288">
+            <a:spAutoFit/>
+          </a:bodyPr>
+          <a:lstStyle/>
+          <a:p>
+            <a:pPr algn="l"/>
+            <a:r>
+              <a:rPr sz="2500" b="1">
+                <a:solidFill>
+                  <a:srgbClr val="0E2D4B"/>
+                </a:solidFill>
+                <a:latin typeface="Noto Sans"/>
+              </a:rPr>
+              <a:t>ANEXO · Clasificación de variables</a:t>
+            </a:r>
+          </a:p>
+        </p:txBody>
+      </p:sp>
+      <p:sp>
+        <p:nvSpPr>
+          <p:cNvPr id="5" name="TextBox 4"/>
+          <p:cNvSpPr txBox="1"/>
+          <p:nvPr/>
+        </p:nvSpPr>
+        <p:spPr>
+          <a:xfrm>
+            <a:off x="11155680" y="384048"/>
+            <a:ext cx="502920" cy="365760"/>
+          </a:xfrm>
+          <a:prstGeom prst="rect">
+            <a:avLst/>
+          </a:prstGeom>
+          <a:noFill/>
+        </p:spPr>
+        <p:txBody>
+          <a:bodyPr wrap="square" anchor="ctr" lIns="18288" rIns="18288" tIns="18288" bIns="18288">
+            <a:spAutoFit/>
+          </a:bodyPr>
+          <a:lstStyle/>
+          <a:p>
+            <a:pPr algn="r"/>
+            <a:r>
+              <a:rPr sz="950" b="1">
+                <a:solidFill>
+                  <a:srgbClr val="596C82"/>
+                </a:solidFill>
+                <a:latin typeface="Noto Sans"/>
+              </a:rPr>
+              <a:t>18</a:t>
+            </a:r>
+          </a:p>
+        </p:txBody>
+      </p:sp>
+      <p:sp>
+        <p:nvSpPr>
+          <p:cNvPr id="6" name="TextBox 5"/>
+          <p:cNvSpPr txBox="1"/>
+          <p:nvPr/>
+        </p:nvSpPr>
+        <p:spPr>
+          <a:xfrm>
+            <a:off x="713232" y="950976"/>
+            <a:ext cx="10424160" cy="347472"/>
+          </a:xfrm>
+          <a:prstGeom prst="rect">
+            <a:avLst/>
+          </a:prstGeom>
+          <a:noFill/>
+        </p:spPr>
+        <p:txBody>
+          <a:bodyPr wrap="square" anchor="ctr" lIns="18288" rIns="18288" tIns="18288" bIns="18288">
+            <a:spAutoFit/>
+          </a:bodyPr>
+          <a:lstStyle/>
+          <a:p>
+            <a:pPr algn="l"/>
+            <a:r>
+              <a:rPr sz="1060" b="0">
+                <a:solidFill>
+                  <a:srgbClr val="596C82"/>
+                </a:solidFill>
+                <a:latin typeface="Noto Sans"/>
+              </a:rPr>
+              <a:t>Clasificamos las variables principales según el criterio trabajado en el Laboratorio 1.</a:t>
+            </a:r>
+          </a:p>
+        </p:txBody>
+      </p:sp>
+      <p:sp>
+        <p:nvSpPr>
+          <p:cNvPr id="7" name="TextBox 6"/>
+          <p:cNvSpPr txBox="1"/>
+          <p:nvPr/>
+        </p:nvSpPr>
+        <p:spPr>
+          <a:xfrm>
+            <a:off x="621792" y="6556248"/>
+            <a:ext cx="6766560" cy="182880"/>
+          </a:xfrm>
+          <a:prstGeom prst="rect">
+            <a:avLst/>
+          </a:prstGeom>
+          <a:noFill/>
+        </p:spPr>
+        <p:txBody>
+          <a:bodyPr wrap="square" anchor="ctr" lIns="18288" rIns="18288" tIns="18288" bIns="18288">
+            <a:spAutoFit/>
+          </a:bodyPr>
+          <a:lstStyle/>
+          <a:p>
+            <a:pPr algn="l"/>
+            <a:r>
+              <a:rPr sz="730" b="0">
+                <a:solidFill>
+                  <a:srgbClr val="758495"/>
+                </a:solidFill>
+                <a:latin typeface="Noto Sans"/>
+              </a:rPr>
+              <a:t>EduBío 360 · Estadística Descriptiva · Biobío 2021</a:t>
+            </a:r>
+          </a:p>
+        </p:txBody>
+      </p:sp>
+      <p:sp>
+        <p:nvSpPr>
+          <p:cNvPr id="8" name="Rounded Rectangle 7"/>
+          <p:cNvSpPr/>
+          <p:nvPr/>
+        </p:nvSpPr>
+        <p:spPr>
+          <a:xfrm>
+            <a:off x="658368" y="1481328"/>
+            <a:ext cx="5321808" cy="4315968"/>
+          </a:xfrm>
+          <a:prstGeom prst="roundRect">
+            <a:avLst/>
+          </a:prstGeom>
+          <a:solidFill>
+            <a:srgbClr val="F6F9FC"/>
+          </a:solidFill>
+          <a:ln w="8890">
+            <a:solidFill>
+              <a:srgbClr val="DFE6ED"/>
+            </a:solidFill>
+          </a:ln>
+        </p:spPr>
+        <p:style>
+          <a:lnRef idx="1">
+            <a:schemeClr val="accent1"/>
+          </a:lnRef>
+          <a:fillRef idx="3">
+            <a:schemeClr val="accent1"/>
+          </a:fillRef>
+          <a:effectRef idx="2">
+            <a:schemeClr val="accent1"/>
+          </a:effectRef>
+          <a:fontRef idx="minor">
+            <a:schemeClr val="lt1"/>
+          </a:fontRef>
+        </p:style>
+        <p:txBody>
+          <a:bodyPr rtlCol="0" anchor="ctr"/>
+          <a:lstStyle/>
+          <a:p>
+            <a:pPr algn="ctr"/>
+          </a:p>
+        </p:txBody>
+      </p:sp>
+      <p:sp>
+        <p:nvSpPr>
+          <p:cNvPr id="9" name="Rounded Rectangle 8"/>
+          <p:cNvSpPr/>
+          <p:nvPr/>
+        </p:nvSpPr>
+        <p:spPr>
+          <a:xfrm>
+            <a:off x="6199632" y="1481328"/>
+            <a:ext cx="5321808" cy="4315968"/>
+          </a:xfrm>
+          <a:prstGeom prst="roundRect">
+            <a:avLst/>
+          </a:prstGeom>
+          <a:solidFill>
+            <a:srgbClr val="F6F9FC"/>
+          </a:solidFill>
+          <a:ln w="8890">
+            <a:solidFill>
+              <a:srgbClr val="DFE6ED"/>
+            </a:solidFill>
+          </a:ln>
+        </p:spPr>
+        <p:style>
+          <a:lnRef idx="1">
+            <a:schemeClr val="accent1"/>
+          </a:lnRef>
+          <a:fillRef idx="3">
+            <a:schemeClr val="accent1"/>
+          </a:fillRef>
+          <a:effectRef idx="2">
+            <a:schemeClr val="accent1"/>
+          </a:effectRef>
+          <a:fontRef idx="minor">
+            <a:schemeClr val="lt1"/>
+          </a:fontRef>
+        </p:style>
+        <p:txBody>
+          <a:bodyPr rtlCol="0" anchor="ctr"/>
+          <a:lstStyle/>
+          <a:p>
+            <a:pPr algn="ctr"/>
+          </a:p>
+        </p:txBody>
+      </p:sp>
+      <p:sp>
+        <p:nvSpPr>
+          <p:cNvPr id="10" name="TextBox 9"/>
+          <p:cNvSpPr txBox="1"/>
+          <p:nvPr/>
+        </p:nvSpPr>
+        <p:spPr>
+          <a:xfrm>
+            <a:off x="932688" y="1737360"/>
+            <a:ext cx="4480560" cy="347472"/>
+          </a:xfrm>
+          <a:prstGeom prst="rect">
+            <a:avLst/>
+          </a:prstGeom>
+          <a:noFill/>
+        </p:spPr>
+        <p:txBody>
+          <a:bodyPr wrap="square" anchor="ctr" lIns="18288" rIns="18288" tIns="18288" bIns="18288">
+            <a:spAutoFit/>
+          </a:bodyPr>
+          <a:lstStyle/>
+          <a:p>
+            <a:pPr algn="l"/>
+            <a:r>
+              <a:rPr sz="1350" b="1">
+                <a:solidFill>
+                  <a:srgbClr val="0E2D4B"/>
+                </a:solidFill>
+                <a:latin typeface="Noto Sans"/>
+              </a:rPr>
+              <a:t>VARIABLES CUALITATIVAS</a:t>
+            </a:r>
+          </a:p>
+        </p:txBody>
+      </p:sp>
+      <p:sp>
+        <p:nvSpPr>
+          <p:cNvPr id="11" name="TextBox 10"/>
+          <p:cNvSpPr txBox="1"/>
+          <p:nvPr/>
+        </p:nvSpPr>
+        <p:spPr>
+          <a:xfrm>
+            <a:off x="6473952" y="1737360"/>
+            <a:ext cx="4480560" cy="347472"/>
+          </a:xfrm>
+          <a:prstGeom prst="rect">
+            <a:avLst/>
+          </a:prstGeom>
+          <a:noFill/>
+        </p:spPr>
+        <p:txBody>
+          <a:bodyPr wrap="square" anchor="ctr" lIns="18288" rIns="18288" tIns="18288" bIns="18288">
+            <a:spAutoFit/>
+          </a:bodyPr>
+          <a:lstStyle/>
+          <a:p>
+            <a:pPr algn="l"/>
+            <a:r>
+              <a:rPr sz="1350" b="1">
+                <a:solidFill>
+                  <a:srgbClr val="0E2D4B"/>
+                </a:solidFill>
+                <a:latin typeface="Noto Sans"/>
+              </a:rPr>
+              <a:t>VARIABLES CUANTITATIVAS</a:t>
+            </a:r>
+          </a:p>
+        </p:txBody>
+      </p:sp>
+      <p:sp>
+        <p:nvSpPr>
+          <p:cNvPr id="12" name="Rounded Rectangle 11"/>
+          <p:cNvSpPr/>
+          <p:nvPr/>
+        </p:nvSpPr>
+        <p:spPr>
+          <a:xfrm>
+            <a:off x="932688" y="2212848"/>
+            <a:ext cx="1051560" cy="310896"/>
+          </a:xfrm>
+          <a:prstGeom prst="roundRect">
+            <a:avLst/>
+          </a:prstGeom>
+          <a:solidFill>
+            <a:srgbClr val="00AD9F"/>
+          </a:solidFill>
+          <a:ln>
+            <a:noFill/>
+          </a:ln>
+        </p:spPr>
+        <p:style>
+          <a:lnRef idx="1">
+            <a:schemeClr val="accent1"/>
+          </a:lnRef>
+          <a:fillRef idx="3">
+            <a:schemeClr val="accent1"/>
+          </a:fillRef>
+          <a:effectRef idx="2">
+            <a:schemeClr val="accent1"/>
+          </a:effectRef>
+          <a:fontRef idx="minor">
+            <a:schemeClr val="lt1"/>
+          </a:fontRef>
+        </p:style>
+        <p:txBody>
+          <a:bodyPr rtlCol="0" anchor="ctr"/>
+          <a:lstStyle/>
+          <a:p>
+            <a:pPr algn="ctr"/>
+          </a:p>
+        </p:txBody>
+      </p:sp>
+      <p:sp>
+        <p:nvSpPr>
+          <p:cNvPr id="13" name="TextBox 12"/>
+          <p:cNvSpPr txBox="1"/>
+          <p:nvPr/>
+        </p:nvSpPr>
+        <p:spPr>
+          <a:xfrm>
+            <a:off x="969264" y="2231136"/>
+            <a:ext cx="978407" cy="256032"/>
+          </a:xfrm>
+          <a:prstGeom prst="rect">
+            <a:avLst/>
+          </a:prstGeom>
+          <a:noFill/>
+        </p:spPr>
+        <p:txBody>
+          <a:bodyPr wrap="square" anchor="ctr" lIns="18288" rIns="18288" tIns="18288" bIns="18288">
+            <a:spAutoFit/>
+          </a:bodyPr>
+          <a:lstStyle/>
+          <a:p>
+            <a:pPr algn="ctr"/>
+            <a:r>
+              <a:rPr sz="819" b="1">
+                <a:solidFill>
+                  <a:srgbClr val="FFFFFF"/>
+                </a:solidFill>
+                <a:latin typeface="Noto Sans"/>
+              </a:rPr>
+              <a:t>Nominal</a:t>
+            </a:r>
+          </a:p>
+        </p:txBody>
+      </p:sp>
+      <p:sp>
+        <p:nvSpPr>
+          <p:cNvPr id="14" name="TextBox 13"/>
+          <p:cNvSpPr txBox="1"/>
+          <p:nvPr/>
+        </p:nvSpPr>
+        <p:spPr>
+          <a:xfrm>
+            <a:off x="2148840" y="2194560"/>
+            <a:ext cx="3401568" cy="310896"/>
+          </a:xfrm>
+          <a:prstGeom prst="rect">
+            <a:avLst/>
+          </a:prstGeom>
+          <a:noFill/>
+        </p:spPr>
+        <p:txBody>
+          <a:bodyPr wrap="square" anchor="ctr" lIns="18288" rIns="18288" tIns="18288" bIns="18288">
+            <a:spAutoFit/>
+          </a:bodyPr>
+          <a:lstStyle/>
+          <a:p>
+            <a:pPr algn="l"/>
+            <a:r>
+              <a:rPr sz="940" b="1">
+                <a:solidFill>
+                  <a:srgbClr val="243B54"/>
+                </a:solidFill>
+                <a:latin typeface="Noto Sans"/>
+              </a:rPr>
+              <a:t>GÉNERO</a:t>
+            </a:r>
+          </a:p>
+        </p:txBody>
+      </p:sp>
+      <p:sp>
+        <p:nvSpPr>
+          <p:cNvPr id="15" name="Rounded Rectangle 14"/>
+          <p:cNvSpPr/>
+          <p:nvPr/>
+        </p:nvSpPr>
+        <p:spPr>
+          <a:xfrm>
+            <a:off x="932688" y="2743200"/>
+            <a:ext cx="1051560" cy="310896"/>
+          </a:xfrm>
+          <a:prstGeom prst="roundRect">
+            <a:avLst/>
+          </a:prstGeom>
+          <a:solidFill>
+            <a:srgbClr val="F59753"/>
+          </a:solidFill>
+          <a:ln>
+            <a:noFill/>
+          </a:ln>
+        </p:spPr>
+        <p:style>
+          <a:lnRef idx="1">
+            <a:schemeClr val="accent1"/>
+          </a:lnRef>
+          <a:fillRef idx="3">
+            <a:schemeClr val="accent1"/>
+          </a:fillRef>
+          <a:effectRef idx="2">
+            <a:schemeClr val="accent1"/>
+          </a:effectRef>
+          <a:fontRef idx="minor">
+            <a:schemeClr val="lt1"/>
+          </a:fontRef>
+        </p:style>
+        <p:txBody>
+          <a:bodyPr rtlCol="0" anchor="ctr"/>
+          <a:lstStyle/>
+          <a:p>
+            <a:pPr algn="ctr"/>
+          </a:p>
+        </p:txBody>
+      </p:sp>
+      <p:sp>
+        <p:nvSpPr>
+          <p:cNvPr id="16" name="TextBox 15"/>
+          <p:cNvSpPr txBox="1"/>
+          <p:nvPr/>
+        </p:nvSpPr>
+        <p:spPr>
+          <a:xfrm>
+            <a:off x="969264" y="2761488"/>
+            <a:ext cx="978407" cy="256032"/>
+          </a:xfrm>
+          <a:prstGeom prst="rect">
+            <a:avLst/>
+          </a:prstGeom>
+          <a:noFill/>
+        </p:spPr>
+        <p:txBody>
+          <a:bodyPr wrap="square" anchor="ctr" lIns="18288" rIns="18288" tIns="18288" bIns="18288">
+            <a:spAutoFit/>
+          </a:bodyPr>
+          <a:lstStyle/>
+          <a:p>
+            <a:pPr algn="ctr"/>
+            <a:r>
+              <a:rPr sz="819" b="1">
+                <a:solidFill>
+                  <a:srgbClr val="FFFFFF"/>
+                </a:solidFill>
+                <a:latin typeface="Noto Sans"/>
+              </a:rPr>
+              <a:t>Ordinal</a:t>
+            </a:r>
+          </a:p>
+        </p:txBody>
+      </p:sp>
+      <p:sp>
+        <p:nvSpPr>
+          <p:cNvPr id="17" name="TextBox 16"/>
+          <p:cNvSpPr txBox="1"/>
+          <p:nvPr/>
+        </p:nvSpPr>
+        <p:spPr>
+          <a:xfrm>
+            <a:off x="2148840" y="2724912"/>
+            <a:ext cx="3401568" cy="310896"/>
+          </a:xfrm>
+          <a:prstGeom prst="rect">
+            <a:avLst/>
+          </a:prstGeom>
+          <a:noFill/>
+        </p:spPr>
+        <p:txBody>
+          <a:bodyPr wrap="square" anchor="ctr" lIns="18288" rIns="18288" tIns="18288" bIns="18288">
+            <a:spAutoFit/>
+          </a:bodyPr>
+          <a:lstStyle/>
+          <a:p>
+            <a:pPr algn="l"/>
+            <a:r>
+              <a:rPr sz="940" b="1">
+                <a:solidFill>
+                  <a:srgbClr val="243B54"/>
+                </a:solidFill>
+                <a:latin typeface="Noto Sans"/>
+              </a:rPr>
+              <a:t>RANGO EDAD</a:t>
+            </a:r>
+          </a:p>
+        </p:txBody>
+      </p:sp>
+      <p:sp>
+        <p:nvSpPr>
+          <p:cNvPr id="18" name="Rounded Rectangle 17"/>
+          <p:cNvSpPr/>
+          <p:nvPr/>
+        </p:nvSpPr>
+        <p:spPr>
+          <a:xfrm>
+            <a:off x="932688" y="3273552"/>
+            <a:ext cx="1051560" cy="310896"/>
+          </a:xfrm>
+          <a:prstGeom prst="roundRect">
+            <a:avLst/>
+          </a:prstGeom>
+          <a:solidFill>
+            <a:srgbClr val="00AD9F"/>
+          </a:solidFill>
+          <a:ln>
+            <a:noFill/>
+          </a:ln>
+        </p:spPr>
+        <p:style>
+          <a:lnRef idx="1">
+            <a:schemeClr val="accent1"/>
+          </a:lnRef>
+          <a:fillRef idx="3">
+            <a:schemeClr val="accent1"/>
+          </a:fillRef>
+          <a:effectRef idx="2">
+            <a:schemeClr val="accent1"/>
+          </a:effectRef>
+          <a:fontRef idx="minor">
+            <a:schemeClr val="lt1"/>
+          </a:fontRef>
+        </p:style>
+        <p:txBody>
+          <a:bodyPr rtlCol="0" anchor="ctr"/>
+          <a:lstStyle/>
+          <a:p>
+            <a:pPr algn="ctr"/>
+          </a:p>
+        </p:txBody>
+      </p:sp>
+      <p:sp>
+        <p:nvSpPr>
+          <p:cNvPr id="19" name="TextBox 18"/>
+          <p:cNvSpPr txBox="1"/>
+          <p:nvPr/>
+        </p:nvSpPr>
+        <p:spPr>
+          <a:xfrm>
+            <a:off x="969264" y="3291840"/>
+            <a:ext cx="978407" cy="256032"/>
+          </a:xfrm>
+          <a:prstGeom prst="rect">
+            <a:avLst/>
+          </a:prstGeom>
+          <a:noFill/>
+        </p:spPr>
+        <p:txBody>
+          <a:bodyPr wrap="square" anchor="ctr" lIns="18288" rIns="18288" tIns="18288" bIns="18288">
+            <a:spAutoFit/>
+          </a:bodyPr>
+          <a:lstStyle/>
+          <a:p>
+            <a:pPr algn="ctr"/>
+            <a:r>
+              <a:rPr sz="819" b="1">
+                <a:solidFill>
+                  <a:srgbClr val="FFFFFF"/>
+                </a:solidFill>
+                <a:latin typeface="Noto Sans"/>
+              </a:rPr>
+              <a:t>Nominal</a:t>
+            </a:r>
+          </a:p>
+        </p:txBody>
+      </p:sp>
+      <p:sp>
+        <p:nvSpPr>
+          <p:cNvPr id="20" name="TextBox 19"/>
+          <p:cNvSpPr txBox="1"/>
+          <p:nvPr/>
+        </p:nvSpPr>
+        <p:spPr>
+          <a:xfrm>
+            <a:off x="2148840" y="3255264"/>
+            <a:ext cx="3401568" cy="310896"/>
+          </a:xfrm>
+          <a:prstGeom prst="rect">
+            <a:avLst/>
+          </a:prstGeom>
+          <a:noFill/>
+        </p:spPr>
+        <p:txBody>
+          <a:bodyPr wrap="square" anchor="ctr" lIns="18288" rIns="18288" tIns="18288" bIns="18288">
+            <a:spAutoFit/>
+          </a:bodyPr>
+          <a:lstStyle/>
+          <a:p>
+            <a:pPr algn="l"/>
+            <a:r>
+              <a:rPr sz="940" b="1">
+                <a:solidFill>
+                  <a:srgbClr val="243B54"/>
+                </a:solidFill>
+                <a:latin typeface="Noto Sans"/>
+              </a:rPr>
+              <a:t>TIPO DE INSTITUCIÓN</a:t>
+            </a:r>
+          </a:p>
+        </p:txBody>
+      </p:sp>
+      <p:sp>
+        <p:nvSpPr>
+          <p:cNvPr id="21" name="Rounded Rectangle 20"/>
+          <p:cNvSpPr/>
+          <p:nvPr/>
+        </p:nvSpPr>
+        <p:spPr>
+          <a:xfrm>
+            <a:off x="932688" y="3803904"/>
+            <a:ext cx="1051560" cy="310896"/>
+          </a:xfrm>
+          <a:prstGeom prst="roundRect">
+            <a:avLst/>
+          </a:prstGeom>
+          <a:solidFill>
+            <a:srgbClr val="00AD9F"/>
+          </a:solidFill>
+          <a:ln>
+            <a:noFill/>
+          </a:ln>
+        </p:spPr>
+        <p:style>
+          <a:lnRef idx="1">
+            <a:schemeClr val="accent1"/>
+          </a:lnRef>
+          <a:fillRef idx="3">
+            <a:schemeClr val="accent1"/>
+          </a:fillRef>
+          <a:effectRef idx="2">
+            <a:schemeClr val="accent1"/>
+          </a:effectRef>
+          <a:fontRef idx="minor">
+            <a:schemeClr val="lt1"/>
+          </a:fontRef>
+        </p:style>
+        <p:txBody>
+          <a:bodyPr rtlCol="0" anchor="ctr"/>
+          <a:lstStyle/>
+          <a:p>
+            <a:pPr algn="ctr"/>
+          </a:p>
+        </p:txBody>
+      </p:sp>
+      <p:sp>
+        <p:nvSpPr>
+          <p:cNvPr id="22" name="TextBox 21"/>
+          <p:cNvSpPr txBox="1"/>
+          <p:nvPr/>
+        </p:nvSpPr>
+        <p:spPr>
+          <a:xfrm>
+            <a:off x="969264" y="3822191"/>
+            <a:ext cx="978407" cy="256032"/>
+          </a:xfrm>
+          <a:prstGeom prst="rect">
+            <a:avLst/>
+          </a:prstGeom>
+          <a:noFill/>
+        </p:spPr>
+        <p:txBody>
+          <a:bodyPr wrap="square" anchor="ctr" lIns="18288" rIns="18288" tIns="18288" bIns="18288">
+            <a:spAutoFit/>
+          </a:bodyPr>
+          <a:lstStyle/>
+          <a:p>
+            <a:pPr algn="ctr"/>
+            <a:r>
+              <a:rPr sz="819" b="1">
+                <a:solidFill>
+                  <a:srgbClr val="FFFFFF"/>
+                </a:solidFill>
+                <a:latin typeface="Noto Sans"/>
+              </a:rPr>
+              <a:t>Nominal</a:t>
+            </a:r>
+          </a:p>
+        </p:txBody>
+      </p:sp>
+      <p:sp>
+        <p:nvSpPr>
+          <p:cNvPr id="23" name="TextBox 22"/>
+          <p:cNvSpPr txBox="1"/>
+          <p:nvPr/>
+        </p:nvSpPr>
+        <p:spPr>
+          <a:xfrm>
+            <a:off x="2148840" y="3785616"/>
+            <a:ext cx="3401568" cy="310896"/>
+          </a:xfrm>
+          <a:prstGeom prst="rect">
+            <a:avLst/>
+          </a:prstGeom>
+          <a:noFill/>
+        </p:spPr>
+        <p:txBody>
+          <a:bodyPr wrap="square" anchor="ctr" lIns="18288" rIns="18288" tIns="18288" bIns="18288">
+            <a:spAutoFit/>
+          </a:bodyPr>
+          <a:lstStyle/>
+          <a:p>
+            <a:pPr algn="l"/>
+            <a:r>
+              <a:rPr sz="940" b="1">
+                <a:solidFill>
+                  <a:srgbClr val="243B54"/>
+                </a:solidFill>
+                <a:latin typeface="Noto Sans"/>
+              </a:rPr>
+              <a:t>NOMBRE CARRERA</a:t>
+            </a:r>
+          </a:p>
+        </p:txBody>
+      </p:sp>
+      <p:sp>
+        <p:nvSpPr>
+          <p:cNvPr id="24" name="Rounded Rectangle 23"/>
+          <p:cNvSpPr/>
+          <p:nvPr/>
+        </p:nvSpPr>
+        <p:spPr>
+          <a:xfrm>
+            <a:off x="932688" y="4334256"/>
+            <a:ext cx="1051560" cy="310896"/>
+          </a:xfrm>
+          <a:prstGeom prst="roundRect">
+            <a:avLst/>
+          </a:prstGeom>
+          <a:solidFill>
+            <a:srgbClr val="00AD9F"/>
+          </a:solidFill>
+          <a:ln>
+            <a:noFill/>
+          </a:ln>
+        </p:spPr>
+        <p:style>
+          <a:lnRef idx="1">
+            <a:schemeClr val="accent1"/>
+          </a:lnRef>
+          <a:fillRef idx="3">
+            <a:schemeClr val="accent1"/>
+          </a:fillRef>
+          <a:effectRef idx="2">
+            <a:schemeClr val="accent1"/>
+          </a:effectRef>
+          <a:fontRef idx="minor">
+            <a:schemeClr val="lt1"/>
+          </a:fontRef>
+        </p:style>
+        <p:txBody>
+          <a:bodyPr rtlCol="0" anchor="ctr"/>
+          <a:lstStyle/>
+          <a:p>
+            <a:pPr algn="ctr"/>
+          </a:p>
+        </p:txBody>
+      </p:sp>
+      <p:sp>
+        <p:nvSpPr>
+          <p:cNvPr id="25" name="TextBox 24"/>
+          <p:cNvSpPr txBox="1"/>
+          <p:nvPr/>
+        </p:nvSpPr>
+        <p:spPr>
+          <a:xfrm>
+            <a:off x="969264" y="4352544"/>
+            <a:ext cx="978407" cy="256032"/>
+          </a:xfrm>
+          <a:prstGeom prst="rect">
+            <a:avLst/>
+          </a:prstGeom>
+          <a:noFill/>
+        </p:spPr>
+        <p:txBody>
+          <a:bodyPr wrap="square" anchor="ctr" lIns="18288" rIns="18288" tIns="18288" bIns="18288">
+            <a:spAutoFit/>
+          </a:bodyPr>
+          <a:lstStyle/>
+          <a:p>
+            <a:pPr algn="ctr"/>
+            <a:r>
+              <a:rPr sz="819" b="1">
+                <a:solidFill>
+                  <a:srgbClr val="FFFFFF"/>
+                </a:solidFill>
+                <a:latin typeface="Noto Sans"/>
+              </a:rPr>
+              <a:t>Nominal</a:t>
+            </a:r>
+          </a:p>
+        </p:txBody>
+      </p:sp>
+      <p:sp>
+        <p:nvSpPr>
+          <p:cNvPr id="26" name="TextBox 25"/>
+          <p:cNvSpPr txBox="1"/>
+          <p:nvPr/>
+        </p:nvSpPr>
+        <p:spPr>
+          <a:xfrm>
+            <a:off x="2148840" y="4315968"/>
+            <a:ext cx="3401568" cy="310896"/>
+          </a:xfrm>
+          <a:prstGeom prst="rect">
+            <a:avLst/>
+          </a:prstGeom>
+          <a:noFill/>
+        </p:spPr>
+        <p:txBody>
+          <a:bodyPr wrap="square" anchor="ctr" lIns="18288" rIns="18288" tIns="18288" bIns="18288">
+            <a:spAutoFit/>
+          </a:bodyPr>
+          <a:lstStyle/>
+          <a:p>
+            <a:pPr algn="l"/>
+            <a:r>
+              <a:rPr sz="940" b="1">
+                <a:solidFill>
+                  <a:srgbClr val="243B54"/>
+                </a:solidFill>
+                <a:latin typeface="Noto Sans"/>
+              </a:rPr>
+              <a:t>ÁREA DEL CONOCIMIENTO</a:t>
+            </a:r>
+          </a:p>
+        </p:txBody>
+      </p:sp>
+      <p:sp>
+        <p:nvSpPr>
+          <p:cNvPr id="27" name="Rounded Rectangle 26"/>
+          <p:cNvSpPr/>
+          <p:nvPr/>
+        </p:nvSpPr>
+        <p:spPr>
+          <a:xfrm>
+            <a:off x="932688" y="4864608"/>
+            <a:ext cx="1051560" cy="310896"/>
+          </a:xfrm>
+          <a:prstGeom prst="roundRect">
+            <a:avLst/>
+          </a:prstGeom>
+          <a:solidFill>
+            <a:srgbClr val="00AD9F"/>
+          </a:solidFill>
+          <a:ln>
+            <a:noFill/>
+          </a:ln>
+        </p:spPr>
+        <p:style>
+          <a:lnRef idx="1">
+            <a:schemeClr val="accent1"/>
+          </a:lnRef>
+          <a:fillRef idx="3">
+            <a:schemeClr val="accent1"/>
+          </a:fillRef>
+          <a:effectRef idx="2">
+            <a:schemeClr val="accent1"/>
+          </a:effectRef>
+          <a:fontRef idx="minor">
+            <a:schemeClr val="lt1"/>
+          </a:fontRef>
+        </p:style>
+        <p:txBody>
+          <a:bodyPr rtlCol="0" anchor="ctr"/>
+          <a:lstStyle/>
+          <a:p>
+            <a:pPr algn="ctr"/>
+          </a:p>
+        </p:txBody>
+      </p:sp>
+      <p:sp>
+        <p:nvSpPr>
+          <p:cNvPr id="28" name="TextBox 27"/>
+          <p:cNvSpPr txBox="1"/>
+          <p:nvPr/>
+        </p:nvSpPr>
+        <p:spPr>
+          <a:xfrm>
+            <a:off x="969264" y="4882896"/>
+            <a:ext cx="978407" cy="256032"/>
+          </a:xfrm>
+          <a:prstGeom prst="rect">
+            <a:avLst/>
+          </a:prstGeom>
+          <a:noFill/>
+        </p:spPr>
+        <p:txBody>
+          <a:bodyPr wrap="square" anchor="ctr" lIns="18288" rIns="18288" tIns="18288" bIns="18288">
+            <a:spAutoFit/>
+          </a:bodyPr>
+          <a:lstStyle/>
+          <a:p>
+            <a:pPr algn="ctr"/>
+            <a:r>
+              <a:rPr sz="819" b="1">
+                <a:solidFill>
+                  <a:srgbClr val="FFFFFF"/>
+                </a:solidFill>
+                <a:latin typeface="Noto Sans"/>
+              </a:rPr>
+              <a:t>Nominal</a:t>
+            </a:r>
+          </a:p>
+        </p:txBody>
+      </p:sp>
+      <p:sp>
+        <p:nvSpPr>
+          <p:cNvPr id="29" name="TextBox 28"/>
+          <p:cNvSpPr txBox="1"/>
+          <p:nvPr/>
+        </p:nvSpPr>
+        <p:spPr>
+          <a:xfrm>
+            <a:off x="2148840" y="4846320"/>
+            <a:ext cx="3401568" cy="310896"/>
+          </a:xfrm>
+          <a:prstGeom prst="rect">
+            <a:avLst/>
+          </a:prstGeom>
+          <a:noFill/>
+        </p:spPr>
+        <p:txBody>
+          <a:bodyPr wrap="square" anchor="ctr" lIns="18288" rIns="18288" tIns="18288" bIns="18288">
+            <a:spAutoFit/>
+          </a:bodyPr>
+          <a:lstStyle/>
+          <a:p>
+            <a:pPr algn="l"/>
+            <a:r>
+              <a:rPr sz="940" b="1">
+                <a:solidFill>
+                  <a:srgbClr val="243B54"/>
+                </a:solidFill>
+                <a:latin typeface="Noto Sans"/>
+              </a:rPr>
+              <a:t>PROVINCIA SEDE</a:t>
+            </a:r>
+          </a:p>
+        </p:txBody>
+      </p:sp>
+      <p:sp>
+        <p:nvSpPr>
+          <p:cNvPr id="30" name="Rounded Rectangle 29"/>
+          <p:cNvSpPr/>
+          <p:nvPr/>
+        </p:nvSpPr>
+        <p:spPr>
+          <a:xfrm>
+            <a:off x="6473952" y="2212848"/>
+            <a:ext cx="1143000" cy="310896"/>
+          </a:xfrm>
+          <a:prstGeom prst="roundRect">
+            <a:avLst/>
+          </a:prstGeom>
+          <a:solidFill>
+            <a:srgbClr val="3AA484"/>
+          </a:solidFill>
+          <a:ln>
+            <a:noFill/>
+          </a:ln>
+        </p:spPr>
+        <p:style>
+          <a:lnRef idx="1">
+            <a:schemeClr val="accent1"/>
+          </a:lnRef>
+          <a:fillRef idx="3">
+            <a:schemeClr val="accent1"/>
+          </a:fillRef>
+          <a:effectRef idx="2">
+            <a:schemeClr val="accent1"/>
+          </a:effectRef>
+          <a:fontRef idx="minor">
+            <a:schemeClr val="lt1"/>
+          </a:fontRef>
+        </p:style>
+        <p:txBody>
+          <a:bodyPr rtlCol="0" anchor="ctr"/>
+          <a:lstStyle/>
+          <a:p>
+            <a:pPr algn="ctr"/>
+          </a:p>
+        </p:txBody>
+      </p:sp>
+      <p:sp>
+        <p:nvSpPr>
+          <p:cNvPr id="31" name="TextBox 30"/>
+          <p:cNvSpPr txBox="1"/>
+          <p:nvPr/>
+        </p:nvSpPr>
+        <p:spPr>
+          <a:xfrm>
+            <a:off x="6510528" y="2231136"/>
+            <a:ext cx="1069848" cy="256032"/>
+          </a:xfrm>
+          <a:prstGeom prst="rect">
+            <a:avLst/>
+          </a:prstGeom>
+          <a:noFill/>
+        </p:spPr>
+        <p:txBody>
+          <a:bodyPr wrap="square" anchor="ctr" lIns="18288" rIns="18288" tIns="18288" bIns="18288">
+            <a:spAutoFit/>
+          </a:bodyPr>
+          <a:lstStyle/>
+          <a:p>
+            <a:pPr algn="ctr"/>
+            <a:r>
+              <a:rPr sz="819" b="1">
+                <a:solidFill>
+                  <a:srgbClr val="FFFFFF"/>
+                </a:solidFill>
+                <a:latin typeface="Noto Sans"/>
+              </a:rPr>
+              <a:t>Continua</a:t>
+            </a:r>
+          </a:p>
+        </p:txBody>
+      </p:sp>
+      <p:sp>
+        <p:nvSpPr>
+          <p:cNvPr id="32" name="TextBox 31"/>
+          <p:cNvSpPr txBox="1"/>
+          <p:nvPr/>
+        </p:nvSpPr>
+        <p:spPr>
+          <a:xfrm>
+            <a:off x="7818120" y="2194560"/>
+            <a:ext cx="3246120" cy="310896"/>
+          </a:xfrm>
+          <a:prstGeom prst="rect">
+            <a:avLst/>
+          </a:prstGeom>
+          <a:noFill/>
+        </p:spPr>
+        <p:txBody>
+          <a:bodyPr wrap="square" anchor="ctr" lIns="18288" rIns="18288" tIns="18288" bIns="18288">
+            <a:spAutoFit/>
+          </a:bodyPr>
+          <a:lstStyle/>
+          <a:p>
+            <a:pPr algn="l"/>
+            <a:r>
+              <a:rPr sz="940" b="1">
+                <a:solidFill>
+                  <a:srgbClr val="243B54"/>
+                </a:solidFill>
+                <a:latin typeface="Noto Sans"/>
+              </a:rPr>
+              <a:t>EDAD</a:t>
+            </a:r>
+          </a:p>
+        </p:txBody>
+      </p:sp>
+      <p:sp>
+        <p:nvSpPr>
+          <p:cNvPr id="33" name="Rounded Rectangle 32"/>
+          <p:cNvSpPr/>
+          <p:nvPr/>
+        </p:nvSpPr>
+        <p:spPr>
+          <a:xfrm>
+            <a:off x="6473952" y="2926080"/>
+            <a:ext cx="1143000" cy="310896"/>
+          </a:xfrm>
+          <a:prstGeom prst="roundRect">
+            <a:avLst/>
+          </a:prstGeom>
+          <a:solidFill>
+            <a:srgbClr val="077596"/>
+          </a:solidFill>
+          <a:ln>
+            <a:noFill/>
+          </a:ln>
+        </p:spPr>
+        <p:style>
+          <a:lnRef idx="1">
+            <a:schemeClr val="accent1"/>
+          </a:lnRef>
+          <a:fillRef idx="3">
+            <a:schemeClr val="accent1"/>
+          </a:fillRef>
+          <a:effectRef idx="2">
+            <a:schemeClr val="accent1"/>
+          </a:effectRef>
+          <a:fontRef idx="minor">
+            <a:schemeClr val="lt1"/>
+          </a:fontRef>
+        </p:style>
+        <p:txBody>
+          <a:bodyPr rtlCol="0" anchor="ctr"/>
+          <a:lstStyle/>
+          <a:p>
+            <a:pPr algn="ctr"/>
+          </a:p>
+        </p:txBody>
+      </p:sp>
+      <p:sp>
+        <p:nvSpPr>
+          <p:cNvPr id="34" name="TextBox 33"/>
+          <p:cNvSpPr txBox="1"/>
+          <p:nvPr/>
+        </p:nvSpPr>
+        <p:spPr>
+          <a:xfrm>
+            <a:off x="6510528" y="2944368"/>
+            <a:ext cx="1069848" cy="256032"/>
+          </a:xfrm>
+          <a:prstGeom prst="rect">
+            <a:avLst/>
+          </a:prstGeom>
+          <a:noFill/>
+        </p:spPr>
+        <p:txBody>
+          <a:bodyPr wrap="square" anchor="ctr" lIns="18288" rIns="18288" tIns="18288" bIns="18288">
+            <a:spAutoFit/>
+          </a:bodyPr>
+          <a:lstStyle/>
+          <a:p>
+            <a:pPr algn="ctr"/>
+            <a:r>
+              <a:rPr sz="819" b="1">
+                <a:solidFill>
+                  <a:srgbClr val="FFFFFF"/>
+                </a:solidFill>
+                <a:latin typeface="Noto Sans"/>
+              </a:rPr>
+              <a:t>Discreta</a:t>
+            </a:r>
+          </a:p>
+        </p:txBody>
+      </p:sp>
+      <p:sp>
+        <p:nvSpPr>
+          <p:cNvPr id="35" name="TextBox 34"/>
+          <p:cNvSpPr txBox="1"/>
+          <p:nvPr/>
+        </p:nvSpPr>
+        <p:spPr>
+          <a:xfrm>
+            <a:off x="7818120" y="2907792"/>
+            <a:ext cx="3246120" cy="310896"/>
+          </a:xfrm>
+          <a:prstGeom prst="rect">
+            <a:avLst/>
+          </a:prstGeom>
+          <a:noFill/>
+        </p:spPr>
+        <p:txBody>
+          <a:bodyPr wrap="square" anchor="ctr" lIns="18288" rIns="18288" tIns="18288" bIns="18288">
+            <a:spAutoFit/>
+          </a:bodyPr>
+          <a:lstStyle/>
+          <a:p>
+            <a:pPr algn="l"/>
+            <a:r>
+              <a:rPr sz="940" b="1">
+                <a:solidFill>
+                  <a:srgbClr val="243B54"/>
+                </a:solidFill>
+                <a:latin typeface="Noto Sans"/>
+              </a:rPr>
+              <a:t>AÑO INGRESO</a:t>
+            </a:r>
+          </a:p>
+        </p:txBody>
+      </p:sp>
+      <p:sp>
+        <p:nvSpPr>
+          <p:cNvPr id="36" name="Rounded Rectangle 35"/>
+          <p:cNvSpPr/>
+          <p:nvPr/>
+        </p:nvSpPr>
+        <p:spPr>
+          <a:xfrm>
+            <a:off x="6473952" y="3639312"/>
+            <a:ext cx="1143000" cy="310896"/>
+          </a:xfrm>
+          <a:prstGeom prst="roundRect">
+            <a:avLst/>
+          </a:prstGeom>
+          <a:solidFill>
+            <a:srgbClr val="3AA484"/>
+          </a:solidFill>
+          <a:ln>
+            <a:noFill/>
+          </a:ln>
+        </p:spPr>
+        <p:style>
+          <a:lnRef idx="1">
+            <a:schemeClr val="accent1"/>
+          </a:lnRef>
+          <a:fillRef idx="3">
+            <a:schemeClr val="accent1"/>
+          </a:fillRef>
+          <a:effectRef idx="2">
+            <a:schemeClr val="accent1"/>
+          </a:effectRef>
+          <a:fontRef idx="minor">
+            <a:schemeClr val="lt1"/>
+          </a:fontRef>
+        </p:style>
+        <p:txBody>
+          <a:bodyPr rtlCol="0" anchor="ctr"/>
+          <a:lstStyle/>
+          <a:p>
+            <a:pPr algn="ctr"/>
+          </a:p>
+        </p:txBody>
+      </p:sp>
+      <p:sp>
+        <p:nvSpPr>
+          <p:cNvPr id="37" name="TextBox 36"/>
+          <p:cNvSpPr txBox="1"/>
+          <p:nvPr/>
+        </p:nvSpPr>
+        <p:spPr>
+          <a:xfrm>
+            <a:off x="6510528" y="3657600"/>
+            <a:ext cx="1069848" cy="256032"/>
+          </a:xfrm>
+          <a:prstGeom prst="rect">
+            <a:avLst/>
+          </a:prstGeom>
+          <a:noFill/>
+        </p:spPr>
+        <p:txBody>
+          <a:bodyPr wrap="square" anchor="ctr" lIns="18288" rIns="18288" tIns="18288" bIns="18288">
+            <a:spAutoFit/>
+          </a:bodyPr>
+          <a:lstStyle/>
+          <a:p>
+            <a:pPr algn="ctr"/>
+            <a:r>
+              <a:rPr sz="819" b="1">
+                <a:solidFill>
+                  <a:srgbClr val="FFFFFF"/>
+                </a:solidFill>
+                <a:latin typeface="Noto Sans"/>
+              </a:rPr>
+              <a:t>Continua</a:t>
+            </a:r>
+          </a:p>
+        </p:txBody>
+      </p:sp>
+      <p:sp>
+        <p:nvSpPr>
+          <p:cNvPr id="38" name="TextBox 37"/>
+          <p:cNvSpPr txBox="1"/>
+          <p:nvPr/>
+        </p:nvSpPr>
+        <p:spPr>
+          <a:xfrm>
+            <a:off x="7818120" y="3621024"/>
+            <a:ext cx="3246120" cy="310896"/>
+          </a:xfrm>
+          <a:prstGeom prst="rect">
+            <a:avLst/>
+          </a:prstGeom>
+          <a:noFill/>
+        </p:spPr>
+        <p:txBody>
+          <a:bodyPr wrap="square" anchor="ctr" lIns="18288" rIns="18288" tIns="18288" bIns="18288">
+            <a:spAutoFit/>
+          </a:bodyPr>
+          <a:lstStyle/>
+          <a:p>
+            <a:pPr algn="l"/>
+            <a:r>
+              <a:rPr sz="940" b="1">
+                <a:solidFill>
+                  <a:srgbClr val="243B54"/>
+                </a:solidFill>
+                <a:latin typeface="Noto Sans"/>
+              </a:rPr>
+              <a:t>DURACIÓN TOTAL (SEMESTRES)</a:t>
+            </a:r>
+          </a:p>
+        </p:txBody>
+      </p:sp>
+      <p:sp>
+        <p:nvSpPr>
+          <p:cNvPr id="39" name="Rounded Rectangle 38"/>
+          <p:cNvSpPr/>
+          <p:nvPr/>
+        </p:nvSpPr>
+        <p:spPr>
+          <a:xfrm>
+            <a:off x="6473952" y="4352544"/>
+            <a:ext cx="1143000" cy="310896"/>
+          </a:xfrm>
+          <a:prstGeom prst="roundRect">
+            <a:avLst/>
+          </a:prstGeom>
+          <a:solidFill>
+            <a:srgbClr val="3AA484"/>
+          </a:solidFill>
+          <a:ln>
+            <a:noFill/>
+          </a:ln>
+        </p:spPr>
+        <p:style>
+          <a:lnRef idx="1">
+            <a:schemeClr val="accent1"/>
+          </a:lnRef>
+          <a:fillRef idx="3">
+            <a:schemeClr val="accent1"/>
+          </a:fillRef>
+          <a:effectRef idx="2">
+            <a:schemeClr val="accent1"/>
+          </a:effectRef>
+          <a:fontRef idx="minor">
+            <a:schemeClr val="lt1"/>
+          </a:fontRef>
+        </p:style>
+        <p:txBody>
+          <a:bodyPr rtlCol="0" anchor="ctr"/>
+          <a:lstStyle/>
+          <a:p>
+            <a:pPr algn="ctr"/>
+          </a:p>
+        </p:txBody>
+      </p:sp>
+      <p:sp>
+        <p:nvSpPr>
+          <p:cNvPr id="40" name="TextBox 39"/>
+          <p:cNvSpPr txBox="1"/>
+          <p:nvPr/>
+        </p:nvSpPr>
+        <p:spPr>
+          <a:xfrm>
+            <a:off x="6510528" y="4370831"/>
+            <a:ext cx="1069848" cy="256032"/>
+          </a:xfrm>
+          <a:prstGeom prst="rect">
+            <a:avLst/>
+          </a:prstGeom>
+          <a:noFill/>
+        </p:spPr>
+        <p:txBody>
+          <a:bodyPr wrap="square" anchor="ctr" lIns="18288" rIns="18288" tIns="18288" bIns="18288">
+            <a:spAutoFit/>
+          </a:bodyPr>
+          <a:lstStyle/>
+          <a:p>
+            <a:pPr algn="ctr"/>
+            <a:r>
+              <a:rPr sz="819" b="1">
+                <a:solidFill>
+                  <a:srgbClr val="FFFFFF"/>
+                </a:solidFill>
+                <a:latin typeface="Noto Sans"/>
+              </a:rPr>
+              <a:t>Continua</a:t>
+            </a:r>
+          </a:p>
+        </p:txBody>
+      </p:sp>
+      <p:sp>
+        <p:nvSpPr>
+          <p:cNvPr id="41" name="TextBox 40"/>
+          <p:cNvSpPr txBox="1"/>
+          <p:nvPr/>
+        </p:nvSpPr>
+        <p:spPr>
+          <a:xfrm>
+            <a:off x="7818120" y="4334256"/>
+            <a:ext cx="3246120" cy="310896"/>
+          </a:xfrm>
+          <a:prstGeom prst="rect">
+            <a:avLst/>
+          </a:prstGeom>
+          <a:noFill/>
+        </p:spPr>
+        <p:txBody>
+          <a:bodyPr wrap="square" anchor="ctr" lIns="18288" rIns="18288" tIns="18288" bIns="18288">
+            <a:spAutoFit/>
+          </a:bodyPr>
+          <a:lstStyle/>
+          <a:p>
+            <a:pPr algn="l"/>
+            <a:r>
+              <a:rPr sz="940" b="1">
+                <a:solidFill>
+                  <a:srgbClr val="243B54"/>
+                </a:solidFill>
+                <a:latin typeface="Noto Sans"/>
+              </a:rPr>
+              <a:t>VALOR ARANCEL (PESOS)</a:t>
+            </a:r>
+          </a:p>
+        </p:txBody>
+      </p:sp>
+      <p:sp>
+        <p:nvSpPr>
+          <p:cNvPr id="42" name="Rounded Rectangle 41"/>
+          <p:cNvSpPr/>
+          <p:nvPr/>
+        </p:nvSpPr>
+        <p:spPr>
+          <a:xfrm>
+            <a:off x="6473952" y="5074920"/>
+            <a:ext cx="4709160" cy="566928"/>
+          </a:xfrm>
+          <a:prstGeom prst="roundRect">
+            <a:avLst/>
+          </a:prstGeom>
+          <a:solidFill>
+            <a:srgbClr val="F6F9FC"/>
+          </a:solidFill>
+          <a:ln w="8890">
+            <a:solidFill>
+              <a:srgbClr val="DFE6ED"/>
+            </a:solidFill>
+          </a:ln>
+        </p:spPr>
+        <p:style>
+          <a:lnRef idx="1">
+            <a:schemeClr val="accent1"/>
+          </a:lnRef>
+          <a:fillRef idx="3">
+            <a:schemeClr val="accent1"/>
+          </a:fillRef>
+          <a:effectRef idx="2">
+            <a:schemeClr val="accent1"/>
+          </a:effectRef>
+          <a:fontRef idx="minor">
+            <a:schemeClr val="lt1"/>
+          </a:fontRef>
+        </p:style>
+        <p:txBody>
+          <a:bodyPr rtlCol="0" anchor="ctr"/>
+          <a:lstStyle/>
+          <a:p>
+            <a:pPr algn="ctr"/>
+          </a:p>
+        </p:txBody>
+      </p:sp>
+      <p:sp>
+        <p:nvSpPr>
+          <p:cNvPr id="43" name="Rectangle 42"/>
+          <p:cNvSpPr/>
+          <p:nvPr/>
+        </p:nvSpPr>
+        <p:spPr>
+          <a:xfrm>
+            <a:off x="6473952" y="5074920"/>
+            <a:ext cx="32004" cy="566928"/>
+          </a:xfrm>
+          <a:prstGeom prst="rect">
+            <a:avLst/>
+          </a:prstGeom>
+          <a:solidFill>
+            <a:srgbClr val="F59753"/>
+          </a:solidFill>
+          <a:ln>
+            <a:noFill/>
+          </a:ln>
+        </p:spPr>
+        <p:style>
+          <a:lnRef idx="1">
+            <a:schemeClr val="accent1"/>
+          </a:lnRef>
+          <a:fillRef idx="3">
+            <a:schemeClr val="accent1"/>
+          </a:fillRef>
+          <a:effectRef idx="2">
+            <a:schemeClr val="accent1"/>
+          </a:effectRef>
+          <a:fontRef idx="minor">
+            <a:schemeClr val="lt1"/>
+          </a:fontRef>
+        </p:style>
+        <p:txBody>
+          <a:bodyPr rtlCol="0" anchor="ctr"/>
+          <a:lstStyle/>
+          <a:p>
+            <a:pPr algn="ctr"/>
+          </a:p>
+        </p:txBody>
+      </p:sp>
+      <p:sp>
+        <p:nvSpPr>
+          <p:cNvPr id="44" name="TextBox 43"/>
+          <p:cNvSpPr txBox="1"/>
+          <p:nvPr/>
+        </p:nvSpPr>
+        <p:spPr>
+          <a:xfrm>
+            <a:off x="6702552" y="5184648"/>
+            <a:ext cx="4297680" cy="219456"/>
+          </a:xfrm>
+          <a:prstGeom prst="rect">
+            <a:avLst/>
+          </a:prstGeom>
+          <a:noFill/>
+        </p:spPr>
+        <p:txBody>
+          <a:bodyPr wrap="square" anchor="ctr" lIns="18288" rIns="18288" tIns="18288" bIns="18288">
+            <a:spAutoFit/>
+          </a:bodyPr>
+          <a:lstStyle/>
+          <a:p>
+            <a:pPr algn="l"/>
+            <a:r>
+              <a:rPr sz="980" b="1">
+                <a:solidFill>
+                  <a:srgbClr val="243B54"/>
+                </a:solidFill>
+                <a:latin typeface="Noto Sans"/>
+              </a:rPr>
+              <a:t>CLAVE</a:t>
+            </a:r>
+          </a:p>
+        </p:txBody>
+      </p:sp>
+      <p:sp>
+        <p:nvSpPr>
+          <p:cNvPr id="45" name="TextBox 44"/>
+          <p:cNvSpPr txBox="1"/>
+          <p:nvPr/>
+        </p:nvSpPr>
+        <p:spPr>
+          <a:xfrm>
+            <a:off x="6702552" y="5422392"/>
+            <a:ext cx="4297680" cy="146303"/>
+          </a:xfrm>
+          <a:prstGeom prst="rect">
+            <a:avLst/>
+          </a:prstGeom>
+          <a:noFill/>
+        </p:spPr>
+        <p:txBody>
+          <a:bodyPr wrap="square" anchor="ctr" lIns="18288" rIns="18288" tIns="18288" bIns="18288">
+            <a:spAutoFit/>
+          </a:bodyPr>
+          <a:lstStyle/>
+          <a:p>
+            <a:pPr algn="l"/>
+            <a:r>
+              <a:rPr sz="890" b="0">
+                <a:solidFill>
+                  <a:srgbClr val="596C82"/>
+                </a:solidFill>
+                <a:latin typeface="Noto Sans"/>
+              </a:rPr>
+              <a:t>Nominal: sin orden · Ordinal: con orden · Discreta: valores contables · Continua: medida en una escala.</a:t>
+            </a:r>
+          </a:p>
+        </p:txBody>
+      </p:sp>
+      <p:sp>
+        <p:nvSpPr>
+          <p:cNvPr id="46" name="Rounded Rectangle 45"/>
+          <p:cNvSpPr/>
+          <p:nvPr/>
+        </p:nvSpPr>
+        <p:spPr>
+          <a:xfrm>
+            <a:off x="658368" y="5916168"/>
+            <a:ext cx="10863072" cy="438912"/>
+          </a:xfrm>
+          <a:prstGeom prst="roundRect">
+            <a:avLst/>
+          </a:prstGeom>
+          <a:solidFill>
+            <a:srgbClr val="F6F9FC"/>
+          </a:solidFill>
+          <a:ln w="8890">
+            <a:solidFill>
+              <a:srgbClr val="DFE6ED"/>
+            </a:solidFill>
+          </a:ln>
+        </p:spPr>
+        <p:style>
+          <a:lnRef idx="1">
+            <a:schemeClr val="accent1"/>
+          </a:lnRef>
+          <a:fillRef idx="3">
+            <a:schemeClr val="accent1"/>
+          </a:fillRef>
+          <a:effectRef idx="2">
+            <a:schemeClr val="accent1"/>
+          </a:effectRef>
+          <a:fontRef idx="minor">
+            <a:schemeClr val="lt1"/>
+          </a:fontRef>
+        </p:style>
+        <p:txBody>
+          <a:bodyPr rtlCol="0" anchor="ctr"/>
+          <a:lstStyle/>
+          <a:p>
+            <a:pPr algn="ctr"/>
+          </a:p>
+        </p:txBody>
+      </p:sp>
+      <p:sp>
+        <p:nvSpPr>
+          <p:cNvPr id="47" name="Rectangle 46"/>
+          <p:cNvSpPr/>
+          <p:nvPr/>
+        </p:nvSpPr>
+        <p:spPr>
+          <a:xfrm>
+            <a:off x="658368" y="5916168"/>
+            <a:ext cx="32004" cy="438912"/>
+          </a:xfrm>
+          <a:prstGeom prst="rect">
+            <a:avLst/>
+          </a:prstGeom>
+          <a:solidFill>
+            <a:srgbClr val="00AD9F"/>
+          </a:solidFill>
+          <a:ln>
+            <a:noFill/>
+          </a:ln>
+        </p:spPr>
+        <p:style>
+          <a:lnRef idx="1">
+            <a:schemeClr val="accent1"/>
+          </a:lnRef>
+          <a:fillRef idx="3">
+            <a:schemeClr val="accent1"/>
+          </a:fillRef>
+          <a:effectRef idx="2">
+            <a:schemeClr val="accent1"/>
+          </a:effectRef>
+          <a:fontRef idx="minor">
+            <a:schemeClr val="lt1"/>
+          </a:fontRef>
+        </p:style>
+        <p:txBody>
+          <a:bodyPr rtlCol="0" anchor="ctr"/>
+          <a:lstStyle/>
+          <a:p>
+            <a:pPr algn="ctr"/>
+          </a:p>
+        </p:txBody>
+      </p:sp>
+      <p:sp>
+        <p:nvSpPr>
+          <p:cNvPr id="48" name="TextBox 47"/>
+          <p:cNvSpPr txBox="1"/>
+          <p:nvPr/>
+        </p:nvSpPr>
+        <p:spPr>
+          <a:xfrm>
+            <a:off x="886968" y="6025896"/>
+            <a:ext cx="10451592" cy="219456"/>
+          </a:xfrm>
+          <a:prstGeom prst="rect">
+            <a:avLst/>
+          </a:prstGeom>
+          <a:noFill/>
+        </p:spPr>
+        <p:txBody>
+          <a:bodyPr wrap="square" anchor="ctr" lIns="18288" rIns="18288" tIns="18288" bIns="18288">
+            <a:spAutoFit/>
+          </a:bodyPr>
+          <a:lstStyle/>
+          <a:p>
+            <a:pPr algn="l"/>
+            <a:r>
+              <a:rPr sz="980" b="1">
+                <a:solidFill>
+                  <a:srgbClr val="243B54"/>
+                </a:solidFill>
+                <a:latin typeface="Noto Sans"/>
+              </a:rPr>
+              <a:t>CRITERIO DEL CURSO</a:t>
+            </a:r>
+          </a:p>
+        </p:txBody>
+      </p:sp>
+      <p:sp>
+        <p:nvSpPr>
+          <p:cNvPr id="49" name="TextBox 48"/>
+          <p:cNvSpPr txBox="1"/>
+          <p:nvPr/>
+        </p:nvSpPr>
+        <p:spPr>
+          <a:xfrm>
+            <a:off x="886968" y="6263640"/>
+            <a:ext cx="10451592" cy="18287"/>
+          </a:xfrm>
+          <a:prstGeom prst="rect">
+            <a:avLst/>
+          </a:prstGeom>
+          <a:noFill/>
+        </p:spPr>
+        <p:txBody>
+          <a:bodyPr wrap="square" anchor="ctr" lIns="18288" rIns="18288" tIns="18288" bIns="18288">
+            <a:spAutoFit/>
+          </a:bodyPr>
+          <a:lstStyle/>
+          <a:p>
+            <a:pPr algn="l"/>
+            <a:r>
+              <a:rPr sz="890" b="0">
+                <a:solidFill>
+                  <a:srgbClr val="596C82"/>
+                </a:solidFill>
+                <a:latin typeface="Noto Sans"/>
+              </a:rPr>
+              <a:t>Seguimos el criterio de los laboratorios del profesor: por ejemplo, Edad se clasifica como cuantitativa continua.</a:t>
             </a:r>
           </a:p>
         </p:txBody>

</xml_diff>